<commit_message>
Panel deck batch: wire is_bank + dynamic period header
Mirror the production pipeline's wiring in the batch renderer so the
panel decks shown on the hosted site exercise the same slide-2 paths:
bank schema for BKMB / ICICI / QNB, dynamic 'Q<n> <YYYY>E' column
header rather than the generic 'ESTIMATE'.

Co-Authored-By: Claude Opus 4.7 (1M context) <noreply@anthropic.com>
</commit_message>
<xml_diff>
--- a/static/decks/0700.HK.pptx
+++ b/static/decks/0700.HK.pptx
@@ -148,154 +148,154 @@
               <c:strCache>
                 <c:ptCount val="50"/>
                 <c:pt idx="0">
-                  <c:v>05-13</c:v>
+                  <c:v>05-15</c:v>
                 </c:pt>
                 <c:pt idx="1">
-                  <c:v>05-20</c:v>
+                  <c:v>05-22</c:v>
                 </c:pt>
                 <c:pt idx="2">
-                  <c:v>05-27</c:v>
+                  <c:v>05-29</c:v>
                 </c:pt>
                 <c:pt idx="3">
-                  <c:v>06-03</c:v>
+                  <c:v>06-05</c:v>
                 </c:pt>
                 <c:pt idx="4">
-                  <c:v>06-10</c:v>
+                  <c:v>06-12</c:v>
                 </c:pt>
                 <c:pt idx="5">
-                  <c:v>06-17</c:v>
+                  <c:v>06-19</c:v>
                 </c:pt>
                 <c:pt idx="6">
-                  <c:v>06-24</c:v>
+                  <c:v>06-26</c:v>
                 </c:pt>
                 <c:pt idx="7">
-                  <c:v>07-02</c:v>
+                  <c:v>07-04</c:v>
                 </c:pt>
                 <c:pt idx="8">
-                  <c:v>07-09</c:v>
+                  <c:v>07-11</c:v>
                 </c:pt>
                 <c:pt idx="9">
-                  <c:v>07-16</c:v>
+                  <c:v>07-18</c:v>
                 </c:pt>
                 <c:pt idx="10">
-                  <c:v>07-23</c:v>
+                  <c:v>07-25</c:v>
                 </c:pt>
                 <c:pt idx="11">
-                  <c:v>07-30</c:v>
+                  <c:v>08-01</c:v>
                 </c:pt>
                 <c:pt idx="12">
-                  <c:v>08-06</c:v>
+                  <c:v>08-08</c:v>
                 </c:pt>
                 <c:pt idx="13">
-                  <c:v>08-13</c:v>
+                  <c:v>08-15</c:v>
                 </c:pt>
                 <c:pt idx="14">
-                  <c:v>08-20</c:v>
+                  <c:v>08-22</c:v>
                 </c:pt>
                 <c:pt idx="15">
-                  <c:v>08-27</c:v>
+                  <c:v>08-29</c:v>
                 </c:pt>
                 <c:pt idx="16">
-                  <c:v>09-03</c:v>
+                  <c:v>09-05</c:v>
                 </c:pt>
                 <c:pt idx="17">
-                  <c:v>09-10</c:v>
+                  <c:v>09-12</c:v>
                 </c:pt>
                 <c:pt idx="18">
-                  <c:v>09-17</c:v>
+                  <c:v>09-19</c:v>
                 </c:pt>
                 <c:pt idx="19">
-                  <c:v>09-24</c:v>
+                  <c:v>09-26</c:v>
                 </c:pt>
                 <c:pt idx="20">
-                  <c:v>10-02</c:v>
+                  <c:v>10-06</c:v>
                 </c:pt>
                 <c:pt idx="21">
-                  <c:v>10-10</c:v>
+                  <c:v>10-14</c:v>
                 </c:pt>
                 <c:pt idx="22">
-                  <c:v>10-17</c:v>
+                  <c:v>10-21</c:v>
                 </c:pt>
                 <c:pt idx="23">
-                  <c:v>10-24</c:v>
+                  <c:v>10-28</c:v>
                 </c:pt>
                 <c:pt idx="24">
-                  <c:v>11-03</c:v>
+                  <c:v>11-05</c:v>
                 </c:pt>
                 <c:pt idx="25">
-                  <c:v>11-10</c:v>
+                  <c:v>11-12</c:v>
                 </c:pt>
                 <c:pt idx="26">
-                  <c:v>11-17</c:v>
+                  <c:v>11-19</c:v>
                 </c:pt>
                 <c:pt idx="27">
-                  <c:v>11-24</c:v>
+                  <c:v>11-26</c:v>
                 </c:pt>
                 <c:pt idx="28">
-                  <c:v>12-01</c:v>
+                  <c:v>12-03</c:v>
                 </c:pt>
                 <c:pt idx="29">
-                  <c:v>12-08</c:v>
+                  <c:v>12-10</c:v>
                 </c:pt>
                 <c:pt idx="30">
-                  <c:v>12-15</c:v>
+                  <c:v>12-17</c:v>
                 </c:pt>
                 <c:pt idx="31">
-                  <c:v>12-22</c:v>
+                  <c:v>12-24</c:v>
                 </c:pt>
                 <c:pt idx="32">
-                  <c:v>12-31</c:v>
+                  <c:v>01-05</c:v>
                 </c:pt>
                 <c:pt idx="33">
-                  <c:v>01-08</c:v>
+                  <c:v>01-12</c:v>
                 </c:pt>
                 <c:pt idx="34">
-                  <c:v>01-15</c:v>
+                  <c:v>01-19</c:v>
                 </c:pt>
                 <c:pt idx="35">
-                  <c:v>01-22</c:v>
+                  <c:v>01-26</c:v>
                 </c:pt>
                 <c:pt idx="36">
-                  <c:v>01-29</c:v>
+                  <c:v>02-02</c:v>
                 </c:pt>
                 <c:pt idx="37">
-                  <c:v>02-05</c:v>
+                  <c:v>02-09</c:v>
                 </c:pt>
                 <c:pt idx="38">
-                  <c:v>02-12</c:v>
+                  <c:v>02-16</c:v>
                 </c:pt>
                 <c:pt idx="39">
-                  <c:v>02-24</c:v>
+                  <c:v>02-26</c:v>
                 </c:pt>
                 <c:pt idx="40">
-                  <c:v>03-03</c:v>
+                  <c:v>03-05</c:v>
                 </c:pt>
                 <c:pt idx="41">
-                  <c:v>03-10</c:v>
+                  <c:v>03-12</c:v>
                 </c:pt>
                 <c:pt idx="42">
-                  <c:v>03-17</c:v>
+                  <c:v>03-19</c:v>
                 </c:pt>
                 <c:pt idx="43">
-                  <c:v>03-24</c:v>
+                  <c:v>03-26</c:v>
                 </c:pt>
                 <c:pt idx="44">
-                  <c:v>03-31</c:v>
+                  <c:v>04-02</c:v>
                 </c:pt>
                 <c:pt idx="45">
-                  <c:v>04-10</c:v>
+                  <c:v>04-14</c:v>
                 </c:pt>
                 <c:pt idx="46">
-                  <c:v>04-17</c:v>
+                  <c:v>04-21</c:v>
                 </c:pt>
                 <c:pt idx="47">
-                  <c:v>04-24</c:v>
+                  <c:v>04-28</c:v>
                 </c:pt>
                 <c:pt idx="48">
-                  <c:v>05-04</c:v>
+                  <c:v>05-06</c:v>
                 </c:pt>
                 <c:pt idx="49">
-                  <c:v>05-11</c:v>
+                  <c:v>05-13</c:v>
                 </c:pt>
               </c:strCache>
             </c:strRef>
@@ -307,154 +307,154 @@
                 <c:formatCode>General</c:formatCode>
                 <c:ptCount val="50"/>
                 <c:pt idx="0">
-                  <c:v>506.0</c:v>
+                  <c:v>520.0</c:v>
                 </c:pt>
                 <c:pt idx="1">
-                  <c:v>517.0</c:v>
+                  <c:v>516.5</c:v>
                 </c:pt>
                 <c:pt idx="2">
+                  <c:v>510.5</c:v>
+                </c:pt>
+                <c:pt idx="3">
+                  <c:v>515.0</c:v>
+                </c:pt>
+                <c:pt idx="4">
+                  <c:v>510.0</c:v>
+                </c:pt>
+                <c:pt idx="5">
+                  <c:v>498.0</c:v>
+                </c:pt>
+                <c:pt idx="6">
+                  <c:v>513.0</c:v>
+                </c:pt>
+                <c:pt idx="7">
+                  <c:v>496.79998779296875</c:v>
+                </c:pt>
+                <c:pt idx="8">
+                  <c:v>496.6000061035156</c:v>
+                </c:pt>
+                <c:pt idx="9">
+                  <c:v>519.0</c:v>
+                </c:pt>
+                <c:pt idx="10">
+                  <c:v>550.5</c:v>
+                </c:pt>
+                <c:pt idx="11">
+                  <c:v>535.0</c:v>
+                </c:pt>
+                <c:pt idx="12">
+                  <c:v>561.0</c:v>
+                </c:pt>
+                <c:pt idx="13">
+                  <c:v>592.0</c:v>
+                </c:pt>
+                <c:pt idx="14">
+                  <c:v>600.0</c:v>
+                </c:pt>
+                <c:pt idx="15">
+                  <c:v>596.5</c:v>
+                </c:pt>
+                <c:pt idx="16">
+                  <c:v>605.5</c:v>
+                </c:pt>
+                <c:pt idx="17">
+                  <c:v>643.5</c:v>
+                </c:pt>
+                <c:pt idx="18">
+                  <c:v>642.5</c:v>
+                </c:pt>
+                <c:pt idx="19">
+                  <c:v>644.0</c:v>
+                </c:pt>
+                <c:pt idx="20">
+                  <c:v>677.5</c:v>
+                </c:pt>
+                <c:pt idx="21">
+                  <c:v>621.0</c:v>
+                </c:pt>
+                <c:pt idx="22">
+                  <c:v>630.5</c:v>
+                </c:pt>
+                <c:pt idx="23">
+                  <c:v>645.0</c:v>
+                </c:pt>
+                <c:pt idx="24">
+                  <c:v>629.0</c:v>
+                </c:pt>
+                <c:pt idx="25">
+                  <c:v>657.0</c:v>
+                </c:pt>
+                <c:pt idx="26">
+                  <c:v>622.5</c:v>
+                </c:pt>
+                <c:pt idx="27">
+                  <c:v>619.5</c:v>
+                </c:pt>
+                <c:pt idx="28">
+                  <c:v>611.0</c:v>
+                </c:pt>
+                <c:pt idx="29">
+                  <c:v>603.0</c:v>
+                </c:pt>
+                <c:pt idx="30">
+                  <c:v>605.0</c:v>
+                </c:pt>
+                <c:pt idx="31">
+                  <c:v>602.5</c:v>
+                </c:pt>
+                <c:pt idx="32">
+                  <c:v>624.5</c:v>
+                </c:pt>
+                <c:pt idx="33">
+                  <c:v>623.0</c:v>
+                </c:pt>
+                <c:pt idx="34">
+                  <c:v>610.0</c:v>
+                </c:pt>
+                <c:pt idx="35">
+                  <c:v>599.5</c:v>
+                </c:pt>
+                <c:pt idx="36">
+                  <c:v>598.5</c:v>
+                </c:pt>
+                <c:pt idx="37">
+                  <c:v>560.0</c:v>
+                </c:pt>
+                <c:pt idx="38">
+                  <c:v>534.5</c:v>
+                </c:pt>
+                <c:pt idx="39">
                   <c:v>512.0</c:v>
                 </c:pt>
-                <c:pt idx="3">
-                  <c:v>505.0</c:v>
-                </c:pt>
-                <c:pt idx="4">
-                  <c:v>513.5</c:v>
-                </c:pt>
-                <c:pt idx="5">
-                  <c:v>513.5</c:v>
-                </c:pt>
-                <c:pt idx="6">
-                  <c:v>509.5</c:v>
-                </c:pt>
-                <c:pt idx="7">
-                  <c:v>501.5</c:v>
-                </c:pt>
-                <c:pt idx="8">
-                  <c:v>497.6000061035156</c:v>
-                </c:pt>
-                <c:pt idx="9">
-                  <c:v>516.5</c:v>
-                </c:pt>
-                <c:pt idx="10">
-                  <c:v>552.0</c:v>
-                </c:pt>
-                <c:pt idx="11">
-                  <c:v>549.0</c:v>
-                </c:pt>
-                <c:pt idx="12">
-                  <c:v>568.5</c:v>
-                </c:pt>
-                <c:pt idx="13">
-                  <c:v>586.0</c:v>
-                </c:pt>
-                <c:pt idx="14">
-                  <c:v>590.5</c:v>
-                </c:pt>
-                <c:pt idx="15">
-                  <c:v>599.0</c:v>
-                </c:pt>
-                <c:pt idx="16">
-                  <c:v>598.5</c:v>
-                </c:pt>
-                <c:pt idx="17">
-                  <c:v>633.5</c:v>
-                </c:pt>
-                <c:pt idx="18">
-                  <c:v>661.5</c:v>
-                </c:pt>
-                <c:pt idx="19">
-                  <c:v>648.5</c:v>
-                </c:pt>
-                <c:pt idx="20">
-                  <c:v>676.5</c:v>
-                </c:pt>
-                <c:pt idx="21">
-                  <c:v>651.5</c:v>
-                </c:pt>
-                <c:pt idx="22">
-                  <c:v>608.0</c:v>
-                </c:pt>
-                <c:pt idx="23">
-                  <c:v>637.5</c:v>
-                </c:pt>
-                <c:pt idx="24">
-                  <c:v>628.0</c:v>
-                </c:pt>
-                <c:pt idx="25">
-                  <c:v>649.5</c:v>
-                </c:pt>
-                <c:pt idx="26">
-                  <c:v>636.5</c:v>
-                </c:pt>
-                <c:pt idx="27">
-                  <c:v>624.5</c:v>
-                </c:pt>
-                <c:pt idx="28">
-                  <c:v>619.5</c:v>
-                </c:pt>
-                <c:pt idx="29">
-                  <c:v>605.0</c:v>
-                </c:pt>
-                <c:pt idx="30">
-                  <c:v>603.0</c:v>
-                </c:pt>
-                <c:pt idx="31">
-                  <c:v>614.5</c:v>
-                </c:pt>
-                <c:pt idx="32">
-                  <c:v>599.0</c:v>
-                </c:pt>
-                <c:pt idx="33">
-                  <c:v>616.0</c:v>
-                </c:pt>
-                <c:pt idx="34">
-                  <c:v>622.0</c:v>
-                </c:pt>
-                <c:pt idx="35">
-                  <c:v>597.5</c:v>
-                </c:pt>
-                <c:pt idx="36">
-                  <c:v>622.0</c:v>
-                </c:pt>
-                <c:pt idx="37">
-                  <c:v>558.5</c:v>
-                </c:pt>
-                <c:pt idx="38">
-                  <c:v>535.5</c:v>
-                </c:pt>
-                <c:pt idx="39">
-                  <c:v>520.0</c:v>
-                </c:pt>
                 <c:pt idx="40">
-                  <c:v>510.5</c:v>
+                  <c:v>502.0</c:v>
                 </c:pt>
                 <c:pt idx="41">
-                  <c:v>553.5</c:v>
+                  <c:v>546.5</c:v>
                 </c:pt>
                 <c:pt idx="42">
-                  <c:v>550.0</c:v>
+                  <c:v>513.0</c:v>
                 </c:pt>
                 <c:pt idx="43">
-                  <c:v>514.0</c:v>
+                  <c:v>495.6000061035156</c:v>
                 </c:pt>
                 <c:pt idx="44">
-                  <c:v>484.0</c:v>
+                  <c:v>489.20001220703125</c:v>
                 </c:pt>
                 <c:pt idx="45">
-                  <c:v>504.5</c:v>
+                  <c:v>493.20001220703125</c:v>
                 </c:pt>
                 <c:pt idx="46">
-                  <c:v>510.5</c:v>
+                  <c:v>519.0</c:v>
                 </c:pt>
                 <c:pt idx="47">
-                  <c:v>493.3999938964844</c:v>
+                  <c:v>473.79998779296875</c:v>
                 </c:pt>
                 <c:pt idx="48">
-                  <c:v>473.0</c:v>
+                  <c:v>463.0</c:v>
                 </c:pt>
                 <c:pt idx="49">
-                  <c:v>464.3999938964844</c:v>
+                  <c:v>462.6000061035156</c:v>
                 </c:pt>
               </c:numCache>
             </c:numRef>
@@ -3784,7 +3784,7 @@
                 </a:solidFill>
                 <a:latin typeface="Georgia"/>
               </a:rPr>
-              <a:t>Tencent Holdings Limited</a:t>
+              <a:t>TENCENT</a:t>
             </a:r>
           </a:p>
         </p:txBody>
@@ -3819,7 +3819,7 @@
                 </a:solidFill>
                 <a:latin typeface="Calibri"/>
               </a:rPr>
-              <a:t>0700.HK  ·  Communication Services  ·  Internet Content &amp; Information  ·  —</a:t>
+              <a:t>0700.HK  ·  Communication Services  ·  Internet Content &amp; Information  ·  HKEX (Hong Kong)</a:t>
             </a:r>
           </a:p>
         </p:txBody>
@@ -4093,7 +4093,7 @@
                 </a:solidFill>
                 <a:latin typeface="Calibri"/>
               </a:rPr>
-              <a:t>BUY</a:t>
+              <a:t>STRONG BUY</a:t>
             </a:r>
           </a:p>
         </p:txBody>
@@ -4253,7 +4253,7 @@
                 </a:solidFill>
                 <a:latin typeface="Calibri"/>
               </a:rPr>
-              <a:t>CNY 725.47</a:t>
+              <a:t>HKD 708.68</a:t>
             </a:r>
           </a:p>
         </p:txBody>
@@ -4413,7 +4413,7 @@
                 </a:solidFill>
                 <a:latin typeface="Calibri"/>
               </a:rPr>
-              <a:t>+58.7%</a:t>
+              <a:t>+55.3%</a:t>
             </a:r>
           </a:p>
         </p:txBody>
@@ -4562,7 +4562,7 @@
                 </a:solidFill>
                 <a:latin typeface="Calibri"/>
               </a:rPr>
-              <a:t>CNY 457.20</a:t>
+              <a:t>HKD 456.40</a:t>
             </a:r>
           </a:p>
         </p:txBody>
@@ -4632,7 +4632,7 @@
                 </a:solidFill>
                 <a:latin typeface="Calibri"/>
               </a:rPr>
-              <a:t>CNY 3.58T</a:t>
+              <a:t>HKD 4.12T</a:t>
             </a:r>
           </a:p>
         </p:txBody>
@@ -4737,7 +4737,7 @@
                 </a:solidFill>
                 <a:latin typeface="Calibri"/>
               </a:rPr>
-              <a:t>P/E (FY EST)</a:t>
+              <a:t>P/E (FY26E)</a:t>
             </a:r>
           </a:p>
         </p:txBody>
@@ -4772,7 +4772,7 @@
                 </a:solidFill>
                 <a:latin typeface="Calibri"/>
               </a:rPr>
-              <a:t>11.8x</a:t>
+              <a:t>15.1x</a:t>
             </a:r>
           </a:p>
         </p:txBody>
@@ -4842,7 +4842,7 @@
                 </a:solidFill>
                 <a:latin typeface="Calibri"/>
               </a:rPr>
-              <a:t>1.76%</a:t>
+              <a:t>1.17%</a:t>
             </a:r>
           </a:p>
         </p:txBody>
@@ -4912,7 +4912,7 @@
                 </a:solidFill>
                 <a:latin typeface="Calibri"/>
               </a:rPr>
-              <a:t>CNY</a:t>
+              <a:t>HKD</a:t>
             </a:r>
           </a:p>
         </p:txBody>
@@ -5057,11 +5057,11 @@
             <a:r>
               <a:rPr sz="1400" b="0">
                 <a:solidFill>
-                  <a:srgbClr val="2F7D4F"/>
-                </a:solidFill>
-                <a:latin typeface="Calibri"/>
-              </a:rPr>
-              <a:t>+1.2%</a:t>
+                  <a:srgbClr val="B83227"/>
+                </a:solidFill>
+                <a:latin typeface="Calibri"/>
+              </a:rPr>
+              <a:t>-0.8%</a:t>
             </a:r>
           </a:p>
         </p:txBody>
@@ -5131,7 +5131,7 @@
                 </a:solidFill>
                 <a:latin typeface="Calibri"/>
               </a:rPr>
-              <a:t>-0.1%</a:t>
+              <a:t>-3.2%</a:t>
             </a:r>
           </a:p>
         </p:txBody>
@@ -5201,7 +5201,7 @@
                 </a:solidFill>
                 <a:latin typeface="Calibri"/>
               </a:rPr>
-              <a:t>-5.6%</a:t>
+              <a:t>-8.5%</a:t>
             </a:r>
           </a:p>
         </p:txBody>
@@ -5271,7 +5271,7 @@
                 </a:solidFill>
                 <a:latin typeface="Calibri"/>
               </a:rPr>
-              <a:t>-17.1%</a:t>
+              <a:t>-16.6%</a:t>
             </a:r>
           </a:p>
         </p:txBody>
@@ -5341,7 +5341,7 @@
                 </a:solidFill>
                 <a:latin typeface="Calibri"/>
               </a:rPr>
-              <a:t>-26.4%</a:t>
+              <a:t>-29.1%</a:t>
             </a:r>
           </a:p>
         </p:txBody>
@@ -5411,7 +5411,7 @@
                 </a:solidFill>
                 <a:latin typeface="Calibri"/>
               </a:rPr>
-              <a:t>-25.8%</a:t>
+              <a:t>-26.7%</a:t>
             </a:r>
           </a:p>
         </p:txBody>
@@ -5525,7 +5525,7 @@
                 </a:solidFill>
                 <a:latin typeface="Calibri"/>
               </a:rPr>
-              <a:t>CNY 457.20</a:t>
+              <a:t>HKD 456.40</a:t>
             </a:r>
           </a:p>
         </p:txBody>
@@ -5560,7 +5560,7 @@
                 </a:solidFill>
                 <a:latin typeface="Calibri"/>
               </a:rPr>
-              <a:t>CNY 677.50</a:t>
+              <a:t>HKD 677.50</a:t>
             </a:r>
           </a:p>
         </p:txBody>
@@ -5659,7 +5659,7 @@
         </p:nvSpPr>
         <p:spPr>
           <a:xfrm>
-            <a:off x="1197863" y="6345936"/>
+            <a:off x="1197864" y="6345936"/>
             <a:ext cx="164592" cy="164592"/>
           </a:xfrm>
           <a:prstGeom prst="diamond">
@@ -5724,7 +5724,7 @@
                 </a:solidFill>
                 <a:latin typeface="Calibri"/>
               </a:rPr>
-              <a:t>Current  CNY 457.20</a:t>
+              <a:t>Current  HKD 456.40</a:t>
             </a:r>
           </a:p>
         </p:txBody>
@@ -5916,7 +5916,7 @@
                 </a:solidFill>
                 <a:latin typeface="Calibri"/>
               </a:rPr>
-              <a:t>Awaiting next print; consensus updates trickling in.</a:t>
+              <a:t>Consensus Strong Buy from 46 analysts covering.</a:t>
             </a:r>
           </a:p>
         </p:txBody>
@@ -6029,7 +6029,7 @@
                 </a:solidFill>
                 <a:latin typeface="Calibri"/>
               </a:rPr>
-              <a:t>Multiple sits in mid-range vs. 5-year history.</a:t>
+              <a:t>Forward P/E 15.1x — anchor for re-rate / de-rate debate.</a:t>
             </a:r>
           </a:p>
         </p:txBody>
@@ -6142,7 +6142,7 @@
                 </a:solidFill>
                 <a:latin typeface="Calibri"/>
               </a:rPr>
-              <a:t>Dividend yield in line with sector peers.</a:t>
+              <a:t>Dividend yield 1.17% supports income mandate fit.</a:t>
             </a:r>
           </a:p>
         </p:txBody>
@@ -6255,7 +6255,7 @@
                 </a:solidFill>
                 <a:latin typeface="Calibri"/>
               </a:rPr>
-              <a:t>Management commentary on forward demand is key.</a:t>
+              <a:t>Target HKD 708.68 (+55.3% vs last close).</a:t>
             </a:r>
           </a:p>
         </p:txBody>
@@ -6368,7 +6368,7 @@
                 </a:solidFill>
                 <a:latin typeface="Calibri"/>
               </a:rPr>
-              <a:t>Macro and feedstock-cost volatility remain top risks.</a:t>
+              <a:t>Crowded long — 43/46 buy ratings raise the expectations bar.</a:t>
             </a:r>
           </a:p>
         </p:txBody>
@@ -6447,7 +6447,7 @@
                 </a:solidFill>
                 <a:latin typeface="Calibri"/>
               </a:rPr>
-              <a:t>Source: investing, marketscreener, yahoo  |  Generated 14 May 2026  |  Analyst: Jabal Research</a:t>
+              <a:t>Source: Investing.com, Yahoo Finance, MarketScreener, World Bank / IMF, iShares  |  Generated 17 May 2026  |  Analyst: Jabal Research</a:t>
             </a:r>
           </a:p>
         </p:txBody>
@@ -6993,7 +6993,7 @@
                 </a:solidFill>
                 <a:latin typeface="Calibri"/>
               </a:rPr>
-              <a:t>Jabal maintains a constructive view into the upcoming print. Tencent Holdings Limited sits in the Communication Services sector (Internet Content &amp; Information). Street consensus is buy (46 analysts covering); consensus target 725.47. The shares trade at a P/E around 11.8x trailing earnings. Macro context: local-economy GDP growth recently at 2.5%. The thesis hinges on three factors: demand trajectory through H2, feedstock/input-cost discipline, and management's tone on guidance during the call. We expect the print itself to be within consensus bounds; the read on forward commentary is the swing factor.</a:t>
+              <a:t>Jabal maintains a constructive view into the upcoming print. TENCENT sits in the Communication Services sector (Internet Content &amp; Information). Street consensus is Strong Buy (46 analysts covering); consensus target 708.68. Macro context: local-economy GDP growth recently at 2.5%. The thesis hinges on three factors: demand trajectory through H2, feedstock/input-cost discipline, and management's tone on guidance during the call. We expect the print itself to be within consensus bounds; the read on forward commentary is the swing factor.</a:t>
             </a:r>
           </a:p>
         </p:txBody>
@@ -7107,7 +7107,7 @@
                 </a:solidFill>
                 <a:latin typeface="Calibri"/>
               </a:rPr>
-              <a:t>Jabal estimates vs. consensus  ·  Local currency unless stated</a:t>
+              <a:t>Jabal estimates vs. consensus  ·  HKD billions unless stated</a:t>
             </a:r>
           </a:p>
         </p:txBody>
@@ -7121,7 +7121,7 @@
         <p:spPr>
           <a:xfrm>
             <a:off x="411480" y="4096512"/>
-            <a:ext cx="2148840" cy="274320"/>
+            <a:ext cx="1965960" cy="274320"/>
           </a:xfrm>
           <a:prstGeom prst="rect">
             <a:avLst/>
@@ -7155,7 +7155,7 @@
         </p:nvSpPr>
         <p:spPr>
           <a:xfrm>
-            <a:off x="2606040" y="4096512"/>
+            <a:off x="2423160" y="4096512"/>
             <a:ext cx="960120" cy="274320"/>
           </a:xfrm>
           <a:prstGeom prst="rect">
@@ -7177,7 +7177,7 @@
                 </a:solidFill>
                 <a:latin typeface="Calibri"/>
               </a:rPr>
-              <a:t>JABAL EST.</a:t>
+              <a:t>Q2 2026E</a:t>
             </a:r>
           </a:p>
         </p:txBody>
@@ -7190,8 +7190,8 @@
         </p:nvSpPr>
         <p:spPr>
           <a:xfrm>
-            <a:off x="3611880" y="4096512"/>
-            <a:ext cx="960120" cy="274320"/>
+            <a:off x="3429000" y="4096512"/>
+            <a:ext cx="868680" cy="274320"/>
           </a:xfrm>
           <a:prstGeom prst="rect">
             <a:avLst/>
@@ -7212,77 +7212,77 @@
                 </a:solidFill>
                 <a:latin typeface="Calibri"/>
               </a:rPr>
+              <a:t>YOY</a:t>
+            </a:r>
+          </a:p>
+        </p:txBody>
+      </p:sp>
+      <p:sp>
+        <p:nvSpPr>
+          <p:cNvPr id="19" name="TextBox 18"/>
+          <p:cNvSpPr txBox="1"/>
+          <p:nvPr/>
+        </p:nvSpPr>
+        <p:spPr>
+          <a:xfrm>
+            <a:off x="4343400" y="4096512"/>
+            <a:ext cx="868680" cy="274320"/>
+          </a:xfrm>
+          <a:prstGeom prst="rect">
+            <a:avLst/>
+          </a:prstGeom>
+          <a:noFill/>
+        </p:spPr>
+        <p:txBody>
+          <a:bodyPr wrap="square" lIns="0" rIns="0" tIns="0" bIns="0" anchor="t">
+            <a:spAutoFit/>
+          </a:bodyPr>
+          <a:lstStyle/>
+          <a:p>
+            <a:pPr algn="r"/>
+            <a:r>
+              <a:rPr sz="850" b="0">
+                <a:solidFill>
+                  <a:srgbClr val="9A9A9A"/>
+                </a:solidFill>
+                <a:latin typeface="Calibri"/>
+              </a:rPr>
+              <a:t>QOQ</a:t>
+            </a:r>
+          </a:p>
+        </p:txBody>
+      </p:sp>
+      <p:sp>
+        <p:nvSpPr>
+          <p:cNvPr id="20" name="TextBox 19"/>
+          <p:cNvSpPr txBox="1"/>
+          <p:nvPr/>
+        </p:nvSpPr>
+        <p:spPr>
+          <a:xfrm>
+            <a:off x="5257800" y="4096512"/>
+            <a:ext cx="1143000" cy="274320"/>
+          </a:xfrm>
+          <a:prstGeom prst="rect">
+            <a:avLst/>
+          </a:prstGeom>
+          <a:noFill/>
+        </p:spPr>
+        <p:txBody>
+          <a:bodyPr wrap="square" lIns="0" rIns="0" tIns="0" bIns="0" anchor="t">
+            <a:spAutoFit/>
+          </a:bodyPr>
+          <a:lstStyle/>
+          <a:p>
+            <a:pPr algn="r"/>
+            <a:r>
+              <a:rPr sz="850" b="0">
+                <a:solidFill>
+                  <a:srgbClr val="9A9A9A"/>
+                </a:solidFill>
+                <a:latin typeface="Calibri"/>
+              </a:rPr>
               <a:t>CONSENSUS</a:t>
-            </a:r>
-          </a:p>
-        </p:txBody>
-      </p:sp>
-      <p:sp>
-        <p:nvSpPr>
-          <p:cNvPr id="19" name="TextBox 18"/>
-          <p:cNvSpPr txBox="1"/>
-          <p:nvPr/>
-        </p:nvSpPr>
-        <p:spPr>
-          <a:xfrm>
-            <a:off x="4617720" y="4096512"/>
-            <a:ext cx="960120" cy="274320"/>
-          </a:xfrm>
-          <a:prstGeom prst="rect">
-            <a:avLst/>
-          </a:prstGeom>
-          <a:noFill/>
-        </p:spPr>
-        <p:txBody>
-          <a:bodyPr wrap="square" lIns="0" rIns="0" tIns="0" bIns="0" anchor="t">
-            <a:spAutoFit/>
-          </a:bodyPr>
-          <a:lstStyle/>
-          <a:p>
-            <a:pPr algn="r"/>
-            <a:r>
-              <a:rPr sz="850" b="0">
-                <a:solidFill>
-                  <a:srgbClr val="9A9A9A"/>
-                </a:solidFill>
-                <a:latin typeface="Calibri"/>
-              </a:rPr>
-              <a:t>Δ VS CONSENSUS</a:t>
-            </a:r>
-          </a:p>
-        </p:txBody>
-      </p:sp>
-      <p:sp>
-        <p:nvSpPr>
-          <p:cNvPr id="20" name="TextBox 19"/>
-          <p:cNvSpPr txBox="1"/>
-          <p:nvPr/>
-        </p:nvSpPr>
-        <p:spPr>
-          <a:xfrm>
-            <a:off x="5623560" y="4096512"/>
-            <a:ext cx="777240" cy="274320"/>
-          </a:xfrm>
-          <a:prstGeom prst="rect">
-            <a:avLst/>
-          </a:prstGeom>
-          <a:noFill/>
-        </p:spPr>
-        <p:txBody>
-          <a:bodyPr wrap="square" lIns="0" rIns="0" tIns="0" bIns="0" anchor="t">
-            <a:spAutoFit/>
-          </a:bodyPr>
-          <a:lstStyle/>
-          <a:p>
-            <a:pPr algn="r"/>
-            <a:r>
-              <a:rPr sz="850" b="0">
-                <a:solidFill>
-                  <a:srgbClr val="9A9A9A"/>
-                </a:solidFill>
-                <a:latin typeface="Calibri"/>
-              </a:rPr>
-              <a:t>YOY</a:t>
             </a:r>
           </a:p>
         </p:txBody>
@@ -7340,7 +7340,7 @@
         <p:spPr>
           <a:xfrm>
             <a:off x="411480" y="4370832"/>
-            <a:ext cx="2148840" cy="274320"/>
+            <a:ext cx="1965960" cy="274320"/>
           </a:xfrm>
           <a:prstGeom prst="rect">
             <a:avLst/>
@@ -7361,7 +7361,7 @@
                 </a:solidFill>
                 <a:latin typeface="Calibri"/>
               </a:rPr>
-              <a:t>EPS — 03/2026</a:t>
+              <a:t>Revenue (HKDB)</a:t>
             </a:r>
           </a:p>
         </p:txBody>
@@ -7374,7 +7374,7 @@
         </p:nvSpPr>
         <p:spPr>
           <a:xfrm>
-            <a:off x="2606040" y="4370832"/>
+            <a:off x="2423160" y="4370832"/>
             <a:ext cx="960120" cy="274320"/>
           </a:xfrm>
           <a:prstGeom prst="rect">
@@ -7409,8 +7409,8 @@
         </p:nvSpPr>
         <p:spPr>
           <a:xfrm>
-            <a:off x="3611880" y="4370832"/>
-            <a:ext cx="960120" cy="274320"/>
+            <a:off x="3429000" y="4370832"/>
+            <a:ext cx="868680" cy="274320"/>
           </a:xfrm>
           <a:prstGeom prst="rect">
             <a:avLst/>
@@ -7427,25 +7427,60 @@
             <a:r>
               <a:rPr sz="1000" b="0">
                 <a:solidFill>
+                  <a:srgbClr val="2F7D4F"/>
+                </a:solidFill>
+                <a:latin typeface="Calibri"/>
+              </a:rPr>
+              <a:t>+10.4%</a:t>
+            </a:r>
+          </a:p>
+        </p:txBody>
+      </p:sp>
+      <p:sp>
+        <p:nvSpPr>
+          <p:cNvPr id="25" name="TextBox 24"/>
+          <p:cNvSpPr txBox="1"/>
+          <p:nvPr/>
+        </p:nvSpPr>
+        <p:spPr>
+          <a:xfrm>
+            <a:off x="4343400" y="4370832"/>
+            <a:ext cx="868680" cy="274320"/>
+          </a:xfrm>
+          <a:prstGeom prst="rect">
+            <a:avLst/>
+          </a:prstGeom>
+          <a:noFill/>
+        </p:spPr>
+        <p:txBody>
+          <a:bodyPr wrap="square" lIns="0" rIns="0" tIns="0" bIns="0" anchor="t">
+            <a:spAutoFit/>
+          </a:bodyPr>
+          <a:lstStyle/>
+          <a:p>
+            <a:pPr algn="r"/>
+            <a:r>
+              <a:rPr sz="1000" b="0">
+                <a:solidFill>
                   <a:srgbClr val="1A1A1A"/>
                 </a:solidFill>
                 <a:latin typeface="Calibri"/>
               </a:rPr>
-              <a:t>7.240</a:t>
-            </a:r>
-          </a:p>
-        </p:txBody>
-      </p:sp>
-      <p:sp>
-        <p:nvSpPr>
-          <p:cNvPr id="25" name="TextBox 24"/>
-          <p:cNvSpPr txBox="1"/>
-          <p:nvPr/>
-        </p:nvSpPr>
-        <p:spPr>
-          <a:xfrm>
-            <a:off x="4617720" y="4370832"/>
-            <a:ext cx="960120" cy="274320"/>
+              <a:t>—</a:t>
+            </a:r>
+          </a:p>
+        </p:txBody>
+      </p:sp>
+      <p:sp>
+        <p:nvSpPr>
+          <p:cNvPr id="26" name="TextBox 25"/>
+          <p:cNvSpPr txBox="1"/>
+          <p:nvPr/>
+        </p:nvSpPr>
+        <p:spPr>
+          <a:xfrm>
+            <a:off x="5257800" y="4370832"/>
+            <a:ext cx="1143000" cy="274320"/>
           </a:xfrm>
           <a:prstGeom prst="rect">
             <a:avLst/>
@@ -7466,42 +7501,7 @@
                 </a:solidFill>
                 <a:latin typeface="Calibri"/>
               </a:rPr>
-              <a:t>—</a:t>
-            </a:r>
-          </a:p>
-        </p:txBody>
-      </p:sp>
-      <p:sp>
-        <p:nvSpPr>
-          <p:cNvPr id="26" name="TextBox 25"/>
-          <p:cNvSpPr txBox="1"/>
-          <p:nvPr/>
-        </p:nvSpPr>
-        <p:spPr>
-          <a:xfrm>
-            <a:off x="5623560" y="4370832"/>
-            <a:ext cx="777240" cy="274320"/>
-          </a:xfrm>
-          <a:prstGeom prst="rect">
-            <a:avLst/>
-          </a:prstGeom>
-          <a:noFill/>
-        </p:spPr>
-        <p:txBody>
-          <a:bodyPr wrap="square" lIns="0" rIns="0" tIns="0" bIns="0" anchor="t">
-            <a:spAutoFit/>
-          </a:bodyPr>
-          <a:lstStyle/>
-          <a:p>
-            <a:pPr algn="r"/>
-            <a:r>
-              <a:rPr sz="1000" b="0">
-                <a:solidFill>
-                  <a:srgbClr val="1A1A1A"/>
-                </a:solidFill>
-                <a:latin typeface="Calibri"/>
-              </a:rPr>
-              <a:t>—</a:t>
+              <a:t>204</a:t>
             </a:r>
           </a:p>
         </p:txBody>
@@ -7558,7 +7558,7 @@
         <p:spPr>
           <a:xfrm>
             <a:off x="411480" y="4645152"/>
-            <a:ext cx="2148840" cy="274320"/>
+            <a:ext cx="1965960" cy="274320"/>
           </a:xfrm>
           <a:prstGeom prst="rect">
             <a:avLst/>
@@ -7579,7 +7579,7 @@
                 </a:solidFill>
                 <a:latin typeface="Calibri"/>
               </a:rPr>
-              <a:t>Revenue — 03/2026</a:t>
+              <a:t>EBITDA (HKDB)</a:t>
             </a:r>
           </a:p>
         </p:txBody>
@@ -7592,7 +7592,7 @@
         </p:nvSpPr>
         <p:spPr>
           <a:xfrm>
-            <a:off x="2606040" y="4645152"/>
+            <a:off x="2423160" y="4645152"/>
             <a:ext cx="960120" cy="274320"/>
           </a:xfrm>
           <a:prstGeom prst="rect">
@@ -7627,7 +7627,147 @@
         </p:nvSpPr>
         <p:spPr>
           <a:xfrm>
-            <a:off x="3611880" y="4645152"/>
+            <a:off x="3429000" y="4645152"/>
+            <a:ext cx="868680" cy="274320"/>
+          </a:xfrm>
+          <a:prstGeom prst="rect">
+            <a:avLst/>
+          </a:prstGeom>
+          <a:noFill/>
+        </p:spPr>
+        <p:txBody>
+          <a:bodyPr wrap="square" lIns="0" rIns="0" tIns="0" bIns="0" anchor="t">
+            <a:spAutoFit/>
+          </a:bodyPr>
+          <a:lstStyle/>
+          <a:p>
+            <a:pPr algn="r"/>
+            <a:r>
+              <a:rPr sz="1000" b="0">
+                <a:solidFill>
+                  <a:srgbClr val="1A1A1A"/>
+                </a:solidFill>
+                <a:latin typeface="Calibri"/>
+              </a:rPr>
+              <a:t>—</a:t>
+            </a:r>
+          </a:p>
+        </p:txBody>
+      </p:sp>
+      <p:sp>
+        <p:nvSpPr>
+          <p:cNvPr id="31" name="TextBox 30"/>
+          <p:cNvSpPr txBox="1"/>
+          <p:nvPr/>
+        </p:nvSpPr>
+        <p:spPr>
+          <a:xfrm>
+            <a:off x="4343400" y="4645152"/>
+            <a:ext cx="868680" cy="274320"/>
+          </a:xfrm>
+          <a:prstGeom prst="rect">
+            <a:avLst/>
+          </a:prstGeom>
+          <a:noFill/>
+        </p:spPr>
+        <p:txBody>
+          <a:bodyPr wrap="square" lIns="0" rIns="0" tIns="0" bIns="0" anchor="t">
+            <a:spAutoFit/>
+          </a:bodyPr>
+          <a:lstStyle/>
+          <a:p>
+            <a:pPr algn="r"/>
+            <a:r>
+              <a:rPr sz="1000" b="0">
+                <a:solidFill>
+                  <a:srgbClr val="1A1A1A"/>
+                </a:solidFill>
+                <a:latin typeface="Calibri"/>
+              </a:rPr>
+              <a:t>—</a:t>
+            </a:r>
+          </a:p>
+        </p:txBody>
+      </p:sp>
+      <p:sp>
+        <p:nvSpPr>
+          <p:cNvPr id="32" name="TextBox 31"/>
+          <p:cNvSpPr txBox="1"/>
+          <p:nvPr/>
+        </p:nvSpPr>
+        <p:spPr>
+          <a:xfrm>
+            <a:off x="5257800" y="4645152"/>
+            <a:ext cx="1143000" cy="274320"/>
+          </a:xfrm>
+          <a:prstGeom prst="rect">
+            <a:avLst/>
+          </a:prstGeom>
+          <a:noFill/>
+        </p:spPr>
+        <p:txBody>
+          <a:bodyPr wrap="square" lIns="0" rIns="0" tIns="0" bIns="0" anchor="t">
+            <a:spAutoFit/>
+          </a:bodyPr>
+          <a:lstStyle/>
+          <a:p>
+            <a:pPr algn="r"/>
+            <a:r>
+              <a:rPr sz="1000" b="0">
+                <a:solidFill>
+                  <a:srgbClr val="1A1A1A"/>
+                </a:solidFill>
+                <a:latin typeface="Calibri"/>
+              </a:rPr>
+              <a:t>—</a:t>
+            </a:r>
+          </a:p>
+        </p:txBody>
+      </p:sp>
+      <p:sp>
+        <p:nvSpPr>
+          <p:cNvPr id="33" name="TextBox 32"/>
+          <p:cNvSpPr txBox="1"/>
+          <p:nvPr/>
+        </p:nvSpPr>
+        <p:spPr>
+          <a:xfrm>
+            <a:off x="411480" y="4919472"/>
+            <a:ext cx="1965960" cy="274320"/>
+          </a:xfrm>
+          <a:prstGeom prst="rect">
+            <a:avLst/>
+          </a:prstGeom>
+          <a:noFill/>
+        </p:spPr>
+        <p:txBody>
+          <a:bodyPr wrap="square" lIns="0" rIns="0" tIns="0" bIns="0" anchor="t">
+            <a:spAutoFit/>
+          </a:bodyPr>
+          <a:lstStyle/>
+          <a:p>
+            <a:pPr algn="l"/>
+            <a:r>
+              <a:rPr sz="1000" b="0">
+                <a:solidFill>
+                  <a:srgbClr val="1A1A1A"/>
+                </a:solidFill>
+                <a:latin typeface="Calibri"/>
+              </a:rPr>
+              <a:t>Net Income (HKDB)</a:t>
+            </a:r>
+          </a:p>
+        </p:txBody>
+      </p:sp>
+      <p:sp>
+        <p:nvSpPr>
+          <p:cNvPr id="34" name="TextBox 33"/>
+          <p:cNvSpPr txBox="1"/>
+          <p:nvPr/>
+        </p:nvSpPr>
+        <p:spPr>
+          <a:xfrm>
+            <a:off x="2423160" y="4919472"/>
             <a:ext cx="960120" cy="274320"/>
           </a:xfrm>
           <a:prstGeom prst="rect">
@@ -7649,21 +7789,21 @@
                 </a:solidFill>
                 <a:latin typeface="Calibri"/>
               </a:rPr>
-              <a:t>198.8B</a:t>
-            </a:r>
-          </a:p>
-        </p:txBody>
-      </p:sp>
-      <p:sp>
-        <p:nvSpPr>
-          <p:cNvPr id="31" name="TextBox 30"/>
-          <p:cNvSpPr txBox="1"/>
-          <p:nvPr/>
-        </p:nvSpPr>
-        <p:spPr>
-          <a:xfrm>
-            <a:off x="4617720" y="4645152"/>
-            <a:ext cx="960120" cy="274320"/>
+              <a:t>—</a:t>
+            </a:r>
+          </a:p>
+        </p:txBody>
+      </p:sp>
+      <p:sp>
+        <p:nvSpPr>
+          <p:cNvPr id="35" name="TextBox 34"/>
+          <p:cNvSpPr txBox="1"/>
+          <p:nvPr/>
+        </p:nvSpPr>
+        <p:spPr>
+          <a:xfrm>
+            <a:off x="3429000" y="4919472"/>
+            <a:ext cx="868680" cy="274320"/>
           </a:xfrm>
           <a:prstGeom prst="rect">
             <a:avLst/>
@@ -7691,14 +7831,14 @@
       </p:sp>
       <p:sp>
         <p:nvSpPr>
-          <p:cNvPr id="32" name="TextBox 31"/>
-          <p:cNvSpPr txBox="1"/>
-          <p:nvPr/>
-        </p:nvSpPr>
-        <p:spPr>
-          <a:xfrm>
-            <a:off x="5623560" y="4645152"/>
-            <a:ext cx="777240" cy="274320"/>
+          <p:cNvPr id="36" name="TextBox 35"/>
+          <p:cNvSpPr txBox="1"/>
+          <p:nvPr/>
+        </p:nvSpPr>
+        <p:spPr>
+          <a:xfrm>
+            <a:off x="4343400" y="4919472"/>
+            <a:ext cx="868680" cy="274320"/>
           </a:xfrm>
           <a:prstGeom prst="rect">
             <a:avLst/>
@@ -7726,154 +7866,14 @@
       </p:sp>
       <p:sp>
         <p:nvSpPr>
-          <p:cNvPr id="33" name="TextBox 32"/>
-          <p:cNvSpPr txBox="1"/>
-          <p:nvPr/>
-        </p:nvSpPr>
-        <p:spPr>
-          <a:xfrm>
-            <a:off x="411480" y="4919472"/>
-            <a:ext cx="2148840" cy="274320"/>
-          </a:xfrm>
-          <a:prstGeom prst="rect">
-            <a:avLst/>
-          </a:prstGeom>
-          <a:noFill/>
-        </p:spPr>
-        <p:txBody>
-          <a:bodyPr wrap="square" lIns="0" rIns="0" tIns="0" bIns="0" anchor="t">
-            <a:spAutoFit/>
-          </a:bodyPr>
-          <a:lstStyle/>
-          <a:p>
-            <a:pPr algn="l"/>
-            <a:r>
-              <a:rPr sz="1000" b="0">
-                <a:solidFill>
-                  <a:srgbClr val="1A1A1A"/>
-                </a:solidFill>
-                <a:latin typeface="Calibri"/>
-              </a:rPr>
-              <a:t>EPS (FY est.)</a:t>
-            </a:r>
-          </a:p>
-        </p:txBody>
-      </p:sp>
-      <p:sp>
-        <p:nvSpPr>
-          <p:cNvPr id="34" name="TextBox 33"/>
-          <p:cNvSpPr txBox="1"/>
-          <p:nvPr/>
-        </p:nvSpPr>
-        <p:spPr>
-          <a:xfrm>
-            <a:off x="2606040" y="4919472"/>
-            <a:ext cx="960120" cy="274320"/>
-          </a:xfrm>
-          <a:prstGeom prst="rect">
-            <a:avLst/>
-          </a:prstGeom>
-          <a:noFill/>
-        </p:spPr>
-        <p:txBody>
-          <a:bodyPr wrap="square" lIns="0" rIns="0" tIns="0" bIns="0" anchor="t">
-            <a:spAutoFit/>
-          </a:bodyPr>
-          <a:lstStyle/>
-          <a:p>
-            <a:pPr algn="r"/>
-            <a:r>
-              <a:rPr sz="1000" b="0">
-                <a:solidFill>
-                  <a:srgbClr val="1A1A1A"/>
-                </a:solidFill>
-                <a:latin typeface="Calibri"/>
-              </a:rPr>
-              <a:t>—</a:t>
-            </a:r>
-          </a:p>
-        </p:txBody>
-      </p:sp>
-      <p:sp>
-        <p:nvSpPr>
-          <p:cNvPr id="35" name="TextBox 34"/>
-          <p:cNvSpPr txBox="1"/>
-          <p:nvPr/>
-        </p:nvSpPr>
-        <p:spPr>
-          <a:xfrm>
-            <a:off x="3611880" y="4919472"/>
-            <a:ext cx="960120" cy="274320"/>
-          </a:xfrm>
-          <a:prstGeom prst="rect">
-            <a:avLst/>
-          </a:prstGeom>
-          <a:noFill/>
-        </p:spPr>
-        <p:txBody>
-          <a:bodyPr wrap="square" lIns="0" rIns="0" tIns="0" bIns="0" anchor="t">
-            <a:spAutoFit/>
-          </a:bodyPr>
-          <a:lstStyle/>
-          <a:p>
-            <a:pPr algn="r"/>
-            <a:r>
-              <a:rPr sz="1000" b="0">
-                <a:solidFill>
-                  <a:srgbClr val="1A1A1A"/>
-                </a:solidFill>
-                <a:latin typeface="Calibri"/>
-              </a:rPr>
-              <a:t>—</a:t>
-            </a:r>
-          </a:p>
-        </p:txBody>
-      </p:sp>
-      <p:sp>
-        <p:nvSpPr>
-          <p:cNvPr id="36" name="TextBox 35"/>
-          <p:cNvSpPr txBox="1"/>
-          <p:nvPr/>
-        </p:nvSpPr>
-        <p:spPr>
-          <a:xfrm>
-            <a:off x="4617720" y="4919472"/>
-            <a:ext cx="960120" cy="274320"/>
-          </a:xfrm>
-          <a:prstGeom prst="rect">
-            <a:avLst/>
-          </a:prstGeom>
-          <a:noFill/>
-        </p:spPr>
-        <p:txBody>
-          <a:bodyPr wrap="square" lIns="0" rIns="0" tIns="0" bIns="0" anchor="t">
-            <a:spAutoFit/>
-          </a:bodyPr>
-          <a:lstStyle/>
-          <a:p>
-            <a:pPr algn="r"/>
-            <a:r>
-              <a:rPr sz="1000" b="0">
-                <a:solidFill>
-                  <a:srgbClr val="1A1A1A"/>
-                </a:solidFill>
-                <a:latin typeface="Calibri"/>
-              </a:rPr>
-              <a:t>—</a:t>
-            </a:r>
-          </a:p>
-        </p:txBody>
-      </p:sp>
-      <p:sp>
-        <p:nvSpPr>
           <p:cNvPr id="37" name="TextBox 36"/>
           <p:cNvSpPr txBox="1"/>
           <p:nvPr/>
         </p:nvSpPr>
         <p:spPr>
           <a:xfrm>
-            <a:off x="5623560" y="4919472"/>
-            <a:ext cx="777240" cy="274320"/>
+            <a:off x="5257800" y="4919472"/>
+            <a:ext cx="1143000" cy="274320"/>
           </a:xfrm>
           <a:prstGeom prst="rect">
             <a:avLst/>
@@ -7951,7 +7951,7 @@
         <p:spPr>
           <a:xfrm>
             <a:off x="411480" y="5193792"/>
-            <a:ext cx="2148840" cy="274320"/>
+            <a:ext cx="1965960" cy="274320"/>
           </a:xfrm>
           <a:prstGeom prst="rect">
             <a:avLst/>
@@ -7972,7 +7972,7 @@
                 </a:solidFill>
                 <a:latin typeface="Calibri"/>
               </a:rPr>
-              <a:t>Revenue (FY est.)</a:t>
+              <a:t>EPS (HKD)</a:t>
             </a:r>
           </a:p>
         </p:txBody>
@@ -7985,7 +7985,7 @@
         </p:nvSpPr>
         <p:spPr>
           <a:xfrm>
-            <a:off x="2606040" y="5193792"/>
+            <a:off x="2423160" y="5193792"/>
             <a:ext cx="960120" cy="274320"/>
           </a:xfrm>
           <a:prstGeom prst="rect">
@@ -8020,7 +8020,147 @@
         </p:nvSpPr>
         <p:spPr>
           <a:xfrm>
-            <a:off x="3611880" y="5193792"/>
+            <a:off x="3429000" y="5193792"/>
+            <a:ext cx="868680" cy="274320"/>
+          </a:xfrm>
+          <a:prstGeom prst="rect">
+            <a:avLst/>
+          </a:prstGeom>
+          <a:noFill/>
+        </p:spPr>
+        <p:txBody>
+          <a:bodyPr wrap="square" lIns="0" rIns="0" tIns="0" bIns="0" anchor="t">
+            <a:spAutoFit/>
+          </a:bodyPr>
+          <a:lstStyle/>
+          <a:p>
+            <a:pPr algn="r"/>
+            <a:r>
+              <a:rPr sz="1000" b="0">
+                <a:solidFill>
+                  <a:srgbClr val="2F7D4F"/>
+                </a:solidFill>
+                <a:latin typeface="Calibri"/>
+              </a:rPr>
+              <a:t>+23.7%</a:t>
+            </a:r>
+          </a:p>
+        </p:txBody>
+      </p:sp>
+      <p:sp>
+        <p:nvSpPr>
+          <p:cNvPr id="42" name="TextBox 41"/>
+          <p:cNvSpPr txBox="1"/>
+          <p:nvPr/>
+        </p:nvSpPr>
+        <p:spPr>
+          <a:xfrm>
+            <a:off x="4343400" y="5193792"/>
+            <a:ext cx="868680" cy="274320"/>
+          </a:xfrm>
+          <a:prstGeom prst="rect">
+            <a:avLst/>
+          </a:prstGeom>
+          <a:noFill/>
+        </p:spPr>
+        <p:txBody>
+          <a:bodyPr wrap="square" lIns="0" rIns="0" tIns="0" bIns="0" anchor="t">
+            <a:spAutoFit/>
+          </a:bodyPr>
+          <a:lstStyle/>
+          <a:p>
+            <a:pPr algn="r"/>
+            <a:r>
+              <a:rPr sz="1000" b="0">
+                <a:solidFill>
+                  <a:srgbClr val="1A1A1A"/>
+                </a:solidFill>
+                <a:latin typeface="Calibri"/>
+              </a:rPr>
+              <a:t>—</a:t>
+            </a:r>
+          </a:p>
+        </p:txBody>
+      </p:sp>
+      <p:sp>
+        <p:nvSpPr>
+          <p:cNvPr id="43" name="TextBox 42"/>
+          <p:cNvSpPr txBox="1"/>
+          <p:nvPr/>
+        </p:nvSpPr>
+        <p:spPr>
+          <a:xfrm>
+            <a:off x="5257800" y="5193792"/>
+            <a:ext cx="1143000" cy="274320"/>
+          </a:xfrm>
+          <a:prstGeom prst="rect">
+            <a:avLst/>
+          </a:prstGeom>
+          <a:noFill/>
+        </p:spPr>
+        <p:txBody>
+          <a:bodyPr wrap="square" lIns="0" rIns="0" tIns="0" bIns="0" anchor="t">
+            <a:spAutoFit/>
+          </a:bodyPr>
+          <a:lstStyle/>
+          <a:p>
+            <a:pPr algn="r"/>
+            <a:r>
+              <a:rPr sz="1000" b="0">
+                <a:solidFill>
+                  <a:srgbClr val="1A1A1A"/>
+                </a:solidFill>
+                <a:latin typeface="Calibri"/>
+              </a:rPr>
+              <a:t>7.42</a:t>
+            </a:r>
+          </a:p>
+        </p:txBody>
+      </p:sp>
+      <p:sp>
+        <p:nvSpPr>
+          <p:cNvPr id="44" name="TextBox 43"/>
+          <p:cNvSpPr txBox="1"/>
+          <p:nvPr/>
+        </p:nvSpPr>
+        <p:spPr>
+          <a:xfrm>
+            <a:off x="411480" y="5468112"/>
+            <a:ext cx="1965960" cy="274320"/>
+          </a:xfrm>
+          <a:prstGeom prst="rect">
+            <a:avLst/>
+          </a:prstGeom>
+          <a:noFill/>
+        </p:spPr>
+        <p:txBody>
+          <a:bodyPr wrap="square" lIns="0" rIns="0" tIns="0" bIns="0" anchor="t">
+            <a:spAutoFit/>
+          </a:bodyPr>
+          <a:lstStyle/>
+          <a:p>
+            <a:pPr algn="l"/>
+            <a:r>
+              <a:rPr sz="1000" b="0">
+                <a:solidFill>
+                  <a:srgbClr val="1A1A1A"/>
+                </a:solidFill>
+                <a:latin typeface="Calibri"/>
+              </a:rPr>
+              <a:t>EBITDA Margin</a:t>
+            </a:r>
+          </a:p>
+        </p:txBody>
+      </p:sp>
+      <p:sp>
+        <p:nvSpPr>
+          <p:cNvPr id="45" name="TextBox 44"/>
+          <p:cNvSpPr txBox="1"/>
+          <p:nvPr/>
+        </p:nvSpPr>
+        <p:spPr>
+          <a:xfrm>
+            <a:off x="2423160" y="5468112"/>
             <a:ext cx="960120" cy="274320"/>
           </a:xfrm>
           <a:prstGeom prst="rect">
@@ -8049,14 +8189,14 @@
       </p:sp>
       <p:sp>
         <p:nvSpPr>
-          <p:cNvPr id="42" name="TextBox 41"/>
-          <p:cNvSpPr txBox="1"/>
-          <p:nvPr/>
-        </p:nvSpPr>
-        <p:spPr>
-          <a:xfrm>
-            <a:off x="4617720" y="5193792"/>
-            <a:ext cx="960120" cy="274320"/>
+          <p:cNvPr id="46" name="TextBox 45"/>
+          <p:cNvSpPr txBox="1"/>
+          <p:nvPr/>
+        </p:nvSpPr>
+        <p:spPr>
+          <a:xfrm>
+            <a:off x="3429000" y="5468112"/>
+            <a:ext cx="868680" cy="274320"/>
           </a:xfrm>
           <a:prstGeom prst="rect">
             <a:avLst/>
@@ -8084,14 +8224,14 @@
       </p:sp>
       <p:sp>
         <p:nvSpPr>
-          <p:cNvPr id="43" name="TextBox 42"/>
-          <p:cNvSpPr txBox="1"/>
-          <p:nvPr/>
-        </p:nvSpPr>
-        <p:spPr>
-          <a:xfrm>
-            <a:off x="5623560" y="5193792"/>
-            <a:ext cx="777240" cy="274320"/>
+          <p:cNvPr id="47" name="TextBox 46"/>
+          <p:cNvSpPr txBox="1"/>
+          <p:nvPr/>
+        </p:nvSpPr>
+        <p:spPr>
+          <a:xfrm>
+            <a:off x="4343400" y="5468112"/>
+            <a:ext cx="868680" cy="274320"/>
           </a:xfrm>
           <a:prstGeom prst="rect">
             <a:avLst/>
@@ -8119,154 +8259,14 @@
       </p:sp>
       <p:sp>
         <p:nvSpPr>
-          <p:cNvPr id="44" name="TextBox 43"/>
-          <p:cNvSpPr txBox="1"/>
-          <p:nvPr/>
-        </p:nvSpPr>
-        <p:spPr>
-          <a:xfrm>
-            <a:off x="411480" y="5468112"/>
-            <a:ext cx="2148840" cy="274320"/>
-          </a:xfrm>
-          <a:prstGeom prst="rect">
-            <a:avLst/>
-          </a:prstGeom>
-          <a:noFill/>
-        </p:spPr>
-        <p:txBody>
-          <a:bodyPr wrap="square" lIns="0" rIns="0" tIns="0" bIns="0" anchor="t">
-            <a:spAutoFit/>
-          </a:bodyPr>
-          <a:lstStyle/>
-          <a:p>
-            <a:pPr algn="l"/>
-            <a:r>
-              <a:rPr sz="1000" b="0">
-                <a:solidFill>
-                  <a:srgbClr val="1A1A1A"/>
-                </a:solidFill>
-                <a:latin typeface="Calibri"/>
-              </a:rPr>
-              <a:t>Dividend yield (TTM)</a:t>
-            </a:r>
-          </a:p>
-        </p:txBody>
-      </p:sp>
-      <p:sp>
-        <p:nvSpPr>
-          <p:cNvPr id="45" name="TextBox 44"/>
-          <p:cNvSpPr txBox="1"/>
-          <p:nvPr/>
-        </p:nvSpPr>
-        <p:spPr>
-          <a:xfrm>
-            <a:off x="2606040" y="5468112"/>
-            <a:ext cx="960120" cy="274320"/>
-          </a:xfrm>
-          <a:prstGeom prst="rect">
-            <a:avLst/>
-          </a:prstGeom>
-          <a:noFill/>
-        </p:spPr>
-        <p:txBody>
-          <a:bodyPr wrap="square" lIns="0" rIns="0" tIns="0" bIns="0" anchor="t">
-            <a:spAutoFit/>
-          </a:bodyPr>
-          <a:lstStyle/>
-          <a:p>
-            <a:pPr algn="r"/>
-            <a:r>
-              <a:rPr sz="1000" b="0">
-                <a:solidFill>
-                  <a:srgbClr val="1A1A1A"/>
-                </a:solidFill>
-                <a:latin typeface="Calibri"/>
-              </a:rPr>
-              <a:t>—</a:t>
-            </a:r>
-          </a:p>
-        </p:txBody>
-      </p:sp>
-      <p:sp>
-        <p:nvSpPr>
-          <p:cNvPr id="46" name="TextBox 45"/>
-          <p:cNvSpPr txBox="1"/>
-          <p:nvPr/>
-        </p:nvSpPr>
-        <p:spPr>
-          <a:xfrm>
-            <a:off x="3611880" y="5468112"/>
-            <a:ext cx="960120" cy="274320"/>
-          </a:xfrm>
-          <a:prstGeom prst="rect">
-            <a:avLst/>
-          </a:prstGeom>
-          <a:noFill/>
-        </p:spPr>
-        <p:txBody>
-          <a:bodyPr wrap="square" lIns="0" rIns="0" tIns="0" bIns="0" anchor="t">
-            <a:spAutoFit/>
-          </a:bodyPr>
-          <a:lstStyle/>
-          <a:p>
-            <a:pPr algn="r"/>
-            <a:r>
-              <a:rPr sz="1000" b="0">
-                <a:solidFill>
-                  <a:srgbClr val="1A1A1A"/>
-                </a:solidFill>
-                <a:latin typeface="Calibri"/>
-              </a:rPr>
-              <a:t>1.76%</a:t>
-            </a:r>
-          </a:p>
-        </p:txBody>
-      </p:sp>
-      <p:sp>
-        <p:nvSpPr>
-          <p:cNvPr id="47" name="TextBox 46"/>
-          <p:cNvSpPr txBox="1"/>
-          <p:nvPr/>
-        </p:nvSpPr>
-        <p:spPr>
-          <a:xfrm>
-            <a:off x="4617720" y="5468112"/>
-            <a:ext cx="960120" cy="274320"/>
-          </a:xfrm>
-          <a:prstGeom prst="rect">
-            <a:avLst/>
-          </a:prstGeom>
-          <a:noFill/>
-        </p:spPr>
-        <p:txBody>
-          <a:bodyPr wrap="square" lIns="0" rIns="0" tIns="0" bIns="0" anchor="t">
-            <a:spAutoFit/>
-          </a:bodyPr>
-          <a:lstStyle/>
-          <a:p>
-            <a:pPr algn="r"/>
-            <a:r>
-              <a:rPr sz="1000" b="0">
-                <a:solidFill>
-                  <a:srgbClr val="1A1A1A"/>
-                </a:solidFill>
-                <a:latin typeface="Calibri"/>
-              </a:rPr>
-              <a:t>—</a:t>
-            </a:r>
-          </a:p>
-        </p:txBody>
-      </p:sp>
-      <p:sp>
-        <p:nvSpPr>
           <p:cNvPr id="48" name="TextBox 47"/>
           <p:cNvSpPr txBox="1"/>
           <p:nvPr/>
         </p:nvSpPr>
         <p:spPr>
           <a:xfrm>
-            <a:off x="5623560" y="5468112"/>
-            <a:ext cx="777240" cy="274320"/>
+            <a:off x="5257800" y="5468112"/>
+            <a:ext cx="1143000" cy="274320"/>
           </a:xfrm>
           <a:prstGeom prst="rect">
             <a:avLst/>
@@ -8322,7 +8322,7 @@
                 </a:solidFill>
                 <a:latin typeface="Calibri"/>
               </a:rPr>
-              <a:t>Next print: May 13, 2026 (period 03/2026)  ·  Consensus: Investing  ·  46 analysts covering</a:t>
+              <a:t>Estimates: Jabal Research  ·  Consensus: Investing (46 analysts)  ·  Bps = basis points</a:t>
             </a:r>
           </a:p>
         </p:txBody>
@@ -8525,7 +8525,7 @@
                 </a:solidFill>
                 <a:latin typeface="Calibri"/>
               </a:rPr>
-              <a:t>EPS missed consensus by 0.8% last quarter; 1 of last 4 quarters above estimates</a:t>
+              <a:t>EPS missed consensus by 0.0% last quarter; 2 of last 4 quarters above estimates</a:t>
             </a:r>
           </a:p>
         </p:txBody>
@@ -9408,7 +9408,7 @@
                 </a:solidFill>
                 <a:latin typeface="Calibri"/>
               </a:rPr>
-              <a:t>Source: investing, marketscreener, yahoo  |  Generated 14 May 2026  |  Analyst: Jabal Research</a:t>
+              <a:t>Source: Investing.com, Yahoo Finance, MarketScreener, World Bank / IMF, iShares  |  Generated 17 May 2026  |  Analyst: Jabal Research</a:t>
             </a:r>
           </a:p>
         </p:txBody>
@@ -9864,7 +9864,7 @@
                 </a:solidFill>
                 <a:latin typeface="Calibri"/>
               </a:rPr>
-              <a:t>52-WEEK PRICE  ·  CNY</a:t>
+              <a:t>52-WEEK PRICE  ·  HKD</a:t>
             </a:r>
           </a:p>
         </p:txBody>
@@ -9952,7 +9952,7 @@
                 </a:solidFill>
                 <a:latin typeface="Calibri"/>
               </a:rPr>
-              <a:t>FY2021</a:t>
+              <a:t>FY2026</a:t>
             </a:r>
           </a:p>
         </p:txBody>
@@ -9966,7 +9966,7 @@
         <p:spPr>
           <a:xfrm>
             <a:off x="4023360" y="2121408"/>
-            <a:ext cx="951547" cy="73152"/>
+            <a:ext cx="1332411" cy="73152"/>
           </a:xfrm>
           <a:prstGeom prst="rect">
             <a:avLst/>
@@ -10008,7 +10008,7 @@
         </p:nvSpPr>
         <p:spPr>
           <a:xfrm>
-            <a:off x="4929187" y="2103120"/>
+            <a:off x="5310051" y="2103120"/>
             <a:ext cx="91440" cy="109728"/>
           </a:xfrm>
           <a:prstGeom prst="ellipse">
@@ -10051,7 +10051,7 @@
         </p:nvSpPr>
         <p:spPr>
           <a:xfrm>
-            <a:off x="5020627" y="2084831"/>
+            <a:off x="5401491" y="2084831"/>
             <a:ext cx="411480" cy="182880"/>
           </a:xfrm>
           <a:prstGeom prst="rect">
@@ -10073,7 +10073,7 @@
                 </a:solidFill>
                 <a:latin typeface="Calibri"/>
               </a:rPr>
-              <a:t>16.1x</a:t>
+              <a:t>15.1x</a:t>
             </a:r>
           </a:p>
         </p:txBody>
@@ -10086,8 +10086,8 @@
         </p:nvSpPr>
         <p:spPr>
           <a:xfrm>
-            <a:off x="3520440" y="2340863"/>
-            <a:ext cx="502920" cy="182880"/>
+            <a:off x="3886200" y="2377439"/>
+            <a:ext cx="365760" cy="164592"/>
           </a:xfrm>
           <a:prstGeom prst="rect">
             <a:avLst/>
@@ -10102,1223 +10102,131 @@
           <a:p>
             <a:pPr algn="l"/>
             <a:r>
-              <a:rPr sz="1000" b="0">
-                <a:solidFill>
-                  <a:srgbClr val="1A1A1A"/>
-                </a:solidFill>
-                <a:latin typeface="Calibri"/>
-              </a:rPr>
-              <a:t>FY2022</a:t>
-            </a:r>
-          </a:p>
-        </p:txBody>
-      </p:sp>
-      <p:sp>
-        <p:nvSpPr>
-          <p:cNvPr id="18" name="Rectangle 17"/>
+              <a:rPr sz="700" b="0">
+                <a:solidFill>
+                  <a:srgbClr val="9A9A9A"/>
+                </a:solidFill>
+                <a:latin typeface="Calibri"/>
+              </a:rPr>
+              <a:t>12x</a:t>
+            </a:r>
+          </a:p>
+        </p:txBody>
+      </p:sp>
+      <p:sp>
+        <p:nvSpPr>
+          <p:cNvPr id="18" name="TextBox 17"/>
+          <p:cNvSpPr txBox="1"/>
+          <p:nvPr/>
+        </p:nvSpPr>
+        <p:spPr>
+          <a:xfrm>
+            <a:off x="4663440" y="2377439"/>
+            <a:ext cx="365760" cy="164592"/>
+          </a:xfrm>
+          <a:prstGeom prst="rect">
+            <a:avLst/>
+          </a:prstGeom>
+          <a:noFill/>
+        </p:spPr>
+        <p:txBody>
+          <a:bodyPr wrap="square" lIns="0" rIns="0" tIns="0" bIns="0" anchor="t">
+            <a:spAutoFit/>
+          </a:bodyPr>
+          <a:lstStyle/>
+          <a:p>
+            <a:pPr algn="l"/>
+            <a:r>
+              <a:rPr sz="700" b="0">
+                <a:solidFill>
+                  <a:srgbClr val="9A9A9A"/>
+                </a:solidFill>
+                <a:latin typeface="Calibri"/>
+              </a:rPr>
+              <a:t>14x</a:t>
+            </a:r>
+          </a:p>
+        </p:txBody>
+      </p:sp>
+      <p:sp>
+        <p:nvSpPr>
+          <p:cNvPr id="19" name="TextBox 18"/>
+          <p:cNvSpPr txBox="1"/>
+          <p:nvPr/>
+        </p:nvSpPr>
+        <p:spPr>
+          <a:xfrm>
+            <a:off x="5440679" y="2377439"/>
+            <a:ext cx="365760" cy="164592"/>
+          </a:xfrm>
+          <a:prstGeom prst="rect">
+            <a:avLst/>
+          </a:prstGeom>
+          <a:noFill/>
+        </p:spPr>
+        <p:txBody>
+          <a:bodyPr wrap="square" lIns="0" rIns="0" tIns="0" bIns="0" anchor="t">
+            <a:spAutoFit/>
+          </a:bodyPr>
+          <a:lstStyle/>
+          <a:p>
+            <a:pPr algn="l"/>
+            <a:r>
+              <a:rPr sz="700" b="0">
+                <a:solidFill>
+                  <a:srgbClr val="9A9A9A"/>
+                </a:solidFill>
+                <a:latin typeface="Calibri"/>
+              </a:rPr>
+              <a:t>16x</a:t>
+            </a:r>
+          </a:p>
+        </p:txBody>
+      </p:sp>
+      <p:sp>
+        <p:nvSpPr>
+          <p:cNvPr id="20" name="TextBox 19"/>
+          <p:cNvSpPr txBox="1"/>
+          <p:nvPr/>
+        </p:nvSpPr>
+        <p:spPr>
+          <a:xfrm>
+            <a:off x="6217920" y="2377439"/>
+            <a:ext cx="365760" cy="164592"/>
+          </a:xfrm>
+          <a:prstGeom prst="rect">
+            <a:avLst/>
+          </a:prstGeom>
+          <a:noFill/>
+        </p:spPr>
+        <p:txBody>
+          <a:bodyPr wrap="square" lIns="0" rIns="0" tIns="0" bIns="0" anchor="t">
+            <a:spAutoFit/>
+          </a:bodyPr>
+          <a:lstStyle/>
+          <a:p>
+            <a:pPr algn="l"/>
+            <a:r>
+              <a:rPr sz="700" b="0">
+                <a:solidFill>
+                  <a:srgbClr val="9A9A9A"/>
+                </a:solidFill>
+                <a:latin typeface="Calibri"/>
+              </a:rPr>
+              <a:t>17x</a:t>
+            </a:r>
+          </a:p>
+        </p:txBody>
+      </p:sp>
+      <p:sp>
+        <p:nvSpPr>
+          <p:cNvPr id="21" name="Diamond 20"/>
           <p:cNvSpPr/>
           <p:nvPr/>
         </p:nvSpPr>
         <p:spPr>
           <a:xfrm>
-            <a:off x="4023360" y="2395727"/>
-            <a:ext cx="837247" cy="73152"/>
-          </a:xfrm>
-          <a:prstGeom prst="rect">
-            <a:avLst/>
-          </a:prstGeom>
-          <a:solidFill>
-            <a:srgbClr val="EFE8DC"/>
-          </a:solidFill>
-          <a:ln>
-            <a:noFill/>
-          </a:ln>
-        </p:spPr>
-        <p:style>
-          <a:lnRef idx="1">
-            <a:schemeClr val="accent1"/>
-          </a:lnRef>
-          <a:fillRef idx="3">
-            <a:schemeClr val="accent1"/>
-          </a:fillRef>
-          <a:effectRef idx="2">
-            <a:schemeClr val="accent1"/>
-          </a:effectRef>
-          <a:fontRef idx="minor">
-            <a:schemeClr val="lt1"/>
-          </a:fontRef>
-        </p:style>
-        <p:txBody>
-          <a:bodyPr rtlCol="0" anchor="ctr"/>
-          <a:lstStyle/>
-          <a:p>
-            <a:pPr algn="ctr"/>
-          </a:p>
-        </p:txBody>
-      </p:sp>
-      <p:sp>
-        <p:nvSpPr>
-          <p:cNvPr id="19" name="Oval 18"/>
-          <p:cNvSpPr/>
-          <p:nvPr/>
-        </p:nvSpPr>
-        <p:spPr>
-          <a:xfrm>
-            <a:off x="4814887" y="2377439"/>
-            <a:ext cx="91440" cy="109728"/>
-          </a:xfrm>
-          <a:prstGeom prst="ellipse">
-            <a:avLst/>
-          </a:prstGeom>
-          <a:solidFill>
-            <a:srgbClr val="7E6849"/>
-          </a:solidFill>
-          <a:ln>
-            <a:noFill/>
-          </a:ln>
-        </p:spPr>
-        <p:style>
-          <a:lnRef idx="1">
-            <a:schemeClr val="accent1"/>
-          </a:lnRef>
-          <a:fillRef idx="3">
-            <a:schemeClr val="accent1"/>
-          </a:fillRef>
-          <a:effectRef idx="2">
-            <a:schemeClr val="accent1"/>
-          </a:effectRef>
-          <a:fontRef idx="minor">
-            <a:schemeClr val="lt1"/>
-          </a:fontRef>
-        </p:style>
-        <p:txBody>
-          <a:bodyPr rtlCol="0" anchor="ctr"/>
-          <a:lstStyle/>
-          <a:p>
-            <a:pPr algn="ctr"/>
-          </a:p>
-        </p:txBody>
-      </p:sp>
-      <p:sp>
-        <p:nvSpPr>
-          <p:cNvPr id="20" name="TextBox 19"/>
-          <p:cNvSpPr txBox="1"/>
-          <p:nvPr/>
-        </p:nvSpPr>
-        <p:spPr>
-          <a:xfrm>
-            <a:off x="4906327" y="2359151"/>
-            <a:ext cx="411480" cy="182880"/>
-          </a:xfrm>
-          <a:prstGeom prst="rect">
-            <a:avLst/>
-          </a:prstGeom>
-          <a:noFill/>
-        </p:spPr>
-        <p:txBody>
-          <a:bodyPr wrap="square" lIns="0" rIns="0" tIns="0" bIns="0" anchor="t">
-            <a:spAutoFit/>
-          </a:bodyPr>
-          <a:lstStyle/>
-          <a:p>
-            <a:pPr algn="l"/>
-            <a:r>
-              <a:rPr sz="1000" b="0">
-                <a:solidFill>
-                  <a:srgbClr val="1A1A1A"/>
-                </a:solidFill>
-                <a:latin typeface="Calibri"/>
-              </a:rPr>
-              <a:t>15.3x</a:t>
-            </a:r>
-          </a:p>
-        </p:txBody>
-      </p:sp>
-      <p:sp>
-        <p:nvSpPr>
-          <p:cNvPr id="21" name="TextBox 20"/>
-          <p:cNvSpPr txBox="1"/>
-          <p:nvPr/>
-        </p:nvSpPr>
-        <p:spPr>
-          <a:xfrm>
-            <a:off x="3520440" y="2615184"/>
-            <a:ext cx="502920" cy="182880"/>
-          </a:xfrm>
-          <a:prstGeom prst="rect">
-            <a:avLst/>
-          </a:prstGeom>
-          <a:noFill/>
-        </p:spPr>
-        <p:txBody>
-          <a:bodyPr wrap="square" lIns="0" rIns="0" tIns="0" bIns="0" anchor="t">
-            <a:spAutoFit/>
-          </a:bodyPr>
-          <a:lstStyle/>
-          <a:p>
-            <a:pPr algn="l"/>
-            <a:r>
-              <a:rPr sz="1000" b="0">
-                <a:solidFill>
-                  <a:srgbClr val="1A1A1A"/>
-                </a:solidFill>
-                <a:latin typeface="Calibri"/>
-              </a:rPr>
-              <a:t>FY2023</a:t>
-            </a:r>
-          </a:p>
-        </p:txBody>
-      </p:sp>
-      <p:sp>
-        <p:nvSpPr>
-          <p:cNvPr id="22" name="Rectangle 21"/>
-          <p:cNvSpPr/>
-          <p:nvPr/>
-        </p:nvSpPr>
-        <p:spPr>
-          <a:xfrm>
-            <a:off x="4023360" y="2670048"/>
-            <a:ext cx="1851660" cy="73152"/>
-          </a:xfrm>
-          <a:prstGeom prst="rect">
-            <a:avLst/>
-          </a:prstGeom>
-          <a:solidFill>
-            <a:srgbClr val="EFE8DC"/>
-          </a:solidFill>
-          <a:ln>
-            <a:noFill/>
-          </a:ln>
-        </p:spPr>
-        <p:style>
-          <a:lnRef idx="1">
-            <a:schemeClr val="accent1"/>
-          </a:lnRef>
-          <a:fillRef idx="3">
-            <a:schemeClr val="accent1"/>
-          </a:fillRef>
-          <a:effectRef idx="2">
-            <a:schemeClr val="accent1"/>
-          </a:effectRef>
-          <a:fontRef idx="minor">
-            <a:schemeClr val="lt1"/>
-          </a:fontRef>
-        </p:style>
-        <p:txBody>
-          <a:bodyPr rtlCol="0" anchor="ctr"/>
-          <a:lstStyle/>
-          <a:p>
-            <a:pPr algn="ctr"/>
-          </a:p>
-        </p:txBody>
-      </p:sp>
-      <p:sp>
-        <p:nvSpPr>
-          <p:cNvPr id="23" name="Oval 22"/>
-          <p:cNvSpPr/>
-          <p:nvPr/>
-        </p:nvSpPr>
-        <p:spPr>
-          <a:xfrm>
-            <a:off x="5829300" y="2651760"/>
-            <a:ext cx="91440" cy="109728"/>
-          </a:xfrm>
-          <a:prstGeom prst="ellipse">
-            <a:avLst/>
-          </a:prstGeom>
-          <a:solidFill>
-            <a:srgbClr val="7E6849"/>
-          </a:solidFill>
-          <a:ln>
-            <a:noFill/>
-          </a:ln>
-        </p:spPr>
-        <p:style>
-          <a:lnRef idx="1">
-            <a:schemeClr val="accent1"/>
-          </a:lnRef>
-          <a:fillRef idx="3">
-            <a:schemeClr val="accent1"/>
-          </a:fillRef>
-          <a:effectRef idx="2">
-            <a:schemeClr val="accent1"/>
-          </a:effectRef>
-          <a:fontRef idx="minor">
-            <a:schemeClr val="lt1"/>
-          </a:fontRef>
-        </p:style>
-        <p:txBody>
-          <a:bodyPr rtlCol="0" anchor="ctr"/>
-          <a:lstStyle/>
-          <a:p>
-            <a:pPr algn="ctr"/>
-          </a:p>
-        </p:txBody>
-      </p:sp>
-      <p:sp>
-        <p:nvSpPr>
-          <p:cNvPr id="24" name="TextBox 23"/>
-          <p:cNvSpPr txBox="1"/>
-          <p:nvPr/>
-        </p:nvSpPr>
-        <p:spPr>
-          <a:xfrm>
-            <a:off x="5920740" y="2633472"/>
-            <a:ext cx="411480" cy="182880"/>
-          </a:xfrm>
-          <a:prstGeom prst="rect">
-            <a:avLst/>
-          </a:prstGeom>
-          <a:noFill/>
-        </p:spPr>
-        <p:txBody>
-          <a:bodyPr wrap="square" lIns="0" rIns="0" tIns="0" bIns="0" anchor="t">
-            <a:spAutoFit/>
-          </a:bodyPr>
-          <a:lstStyle/>
-          <a:p>
-            <a:pPr algn="l"/>
-            <a:r>
-              <a:rPr sz="1000" b="0">
-                <a:solidFill>
-                  <a:srgbClr val="1A1A1A"/>
-                </a:solidFill>
-                <a:latin typeface="Calibri"/>
-              </a:rPr>
-              <a:t>22.4x</a:t>
-            </a:r>
-          </a:p>
-        </p:txBody>
-      </p:sp>
-      <p:sp>
-        <p:nvSpPr>
-          <p:cNvPr id="25" name="TextBox 24"/>
-          <p:cNvSpPr txBox="1"/>
-          <p:nvPr/>
-        </p:nvSpPr>
-        <p:spPr>
-          <a:xfrm>
-            <a:off x="3520440" y="2889503"/>
-            <a:ext cx="502920" cy="182880"/>
-          </a:xfrm>
-          <a:prstGeom prst="rect">
-            <a:avLst/>
-          </a:prstGeom>
-          <a:noFill/>
-        </p:spPr>
-        <p:txBody>
-          <a:bodyPr wrap="square" lIns="0" rIns="0" tIns="0" bIns="0" anchor="t">
-            <a:spAutoFit/>
-          </a:bodyPr>
-          <a:lstStyle/>
-          <a:p>
-            <a:pPr algn="l"/>
-            <a:r>
-              <a:rPr sz="1000" b="0">
-                <a:solidFill>
-                  <a:srgbClr val="1A1A1A"/>
-                </a:solidFill>
-                <a:latin typeface="Calibri"/>
-              </a:rPr>
-              <a:t>FY2024</a:t>
-            </a:r>
-          </a:p>
-        </p:txBody>
-      </p:sp>
-      <p:sp>
-        <p:nvSpPr>
-          <p:cNvPr id="26" name="Rectangle 25"/>
-          <p:cNvSpPr/>
-          <p:nvPr/>
-        </p:nvSpPr>
-        <p:spPr>
-          <a:xfrm>
-            <a:off x="4023360" y="2944368"/>
-            <a:ext cx="1380172" cy="73152"/>
-          </a:xfrm>
-          <a:prstGeom prst="rect">
-            <a:avLst/>
-          </a:prstGeom>
-          <a:solidFill>
-            <a:srgbClr val="EFE8DC"/>
-          </a:solidFill>
-          <a:ln>
-            <a:noFill/>
-          </a:ln>
-        </p:spPr>
-        <p:style>
-          <a:lnRef idx="1">
-            <a:schemeClr val="accent1"/>
-          </a:lnRef>
-          <a:fillRef idx="3">
-            <a:schemeClr val="accent1"/>
-          </a:fillRef>
-          <a:effectRef idx="2">
-            <a:schemeClr val="accent1"/>
-          </a:effectRef>
-          <a:fontRef idx="minor">
-            <a:schemeClr val="lt1"/>
-          </a:fontRef>
-        </p:style>
-        <p:txBody>
-          <a:bodyPr rtlCol="0" anchor="ctr"/>
-          <a:lstStyle/>
-          <a:p>
-            <a:pPr algn="ctr"/>
-          </a:p>
-        </p:txBody>
-      </p:sp>
-      <p:sp>
-        <p:nvSpPr>
-          <p:cNvPr id="27" name="Oval 26"/>
-          <p:cNvSpPr/>
-          <p:nvPr/>
-        </p:nvSpPr>
-        <p:spPr>
-          <a:xfrm>
-            <a:off x="5357812" y="2926079"/>
-            <a:ext cx="91440" cy="109728"/>
-          </a:xfrm>
-          <a:prstGeom prst="ellipse">
-            <a:avLst/>
-          </a:prstGeom>
-          <a:solidFill>
-            <a:srgbClr val="7E6849"/>
-          </a:solidFill>
-          <a:ln>
-            <a:noFill/>
-          </a:ln>
-        </p:spPr>
-        <p:style>
-          <a:lnRef idx="1">
-            <a:schemeClr val="accent1"/>
-          </a:lnRef>
-          <a:fillRef idx="3">
-            <a:schemeClr val="accent1"/>
-          </a:fillRef>
-          <a:effectRef idx="2">
-            <a:schemeClr val="accent1"/>
-          </a:effectRef>
-          <a:fontRef idx="minor">
-            <a:schemeClr val="lt1"/>
-          </a:fontRef>
-        </p:style>
-        <p:txBody>
-          <a:bodyPr rtlCol="0" anchor="ctr"/>
-          <a:lstStyle/>
-          <a:p>
-            <a:pPr algn="ctr"/>
-          </a:p>
-        </p:txBody>
-      </p:sp>
-      <p:sp>
-        <p:nvSpPr>
-          <p:cNvPr id="28" name="TextBox 27"/>
-          <p:cNvSpPr txBox="1"/>
-          <p:nvPr/>
-        </p:nvSpPr>
-        <p:spPr>
-          <a:xfrm>
-            <a:off x="5449252" y="2907791"/>
-            <a:ext cx="411480" cy="182880"/>
-          </a:xfrm>
-          <a:prstGeom prst="rect">
-            <a:avLst/>
-          </a:prstGeom>
-          <a:noFill/>
-        </p:spPr>
-        <p:txBody>
-          <a:bodyPr wrap="square" lIns="0" rIns="0" tIns="0" bIns="0" anchor="t">
-            <a:spAutoFit/>
-          </a:bodyPr>
-          <a:lstStyle/>
-          <a:p>
-            <a:pPr algn="l"/>
-            <a:r>
-              <a:rPr sz="1000" b="0">
-                <a:solidFill>
-                  <a:srgbClr val="1A1A1A"/>
-                </a:solidFill>
-                <a:latin typeface="Calibri"/>
-              </a:rPr>
-              <a:t>19.1x</a:t>
-            </a:r>
-          </a:p>
-        </p:txBody>
-      </p:sp>
-      <p:sp>
-        <p:nvSpPr>
-          <p:cNvPr id="29" name="TextBox 28"/>
-          <p:cNvSpPr txBox="1"/>
-          <p:nvPr/>
-        </p:nvSpPr>
-        <p:spPr>
-          <a:xfrm>
-            <a:off x="3520440" y="3163824"/>
-            <a:ext cx="502920" cy="182880"/>
-          </a:xfrm>
-          <a:prstGeom prst="rect">
-            <a:avLst/>
-          </a:prstGeom>
-          <a:noFill/>
-        </p:spPr>
-        <p:txBody>
-          <a:bodyPr wrap="square" lIns="0" rIns="0" tIns="0" bIns="0" anchor="t">
-            <a:spAutoFit/>
-          </a:bodyPr>
-          <a:lstStyle/>
-          <a:p>
-            <a:pPr algn="l"/>
-            <a:r>
-              <a:rPr sz="1000" b="0">
-                <a:solidFill>
-                  <a:srgbClr val="1A1A1A"/>
-                </a:solidFill>
-                <a:latin typeface="Calibri"/>
-              </a:rPr>
-              <a:t>FY2025</a:t>
-            </a:r>
-          </a:p>
-        </p:txBody>
-      </p:sp>
-      <p:sp>
-        <p:nvSpPr>
-          <p:cNvPr id="30" name="Rectangle 29"/>
-          <p:cNvSpPr/>
-          <p:nvPr/>
-        </p:nvSpPr>
-        <p:spPr>
-          <a:xfrm>
-            <a:off x="4023360" y="3218688"/>
-            <a:ext cx="1837372" cy="73152"/>
-          </a:xfrm>
-          <a:prstGeom prst="rect">
-            <a:avLst/>
-          </a:prstGeom>
-          <a:solidFill>
-            <a:srgbClr val="EFE8DC"/>
-          </a:solidFill>
-          <a:ln>
-            <a:noFill/>
-          </a:ln>
-        </p:spPr>
-        <p:style>
-          <a:lnRef idx="1">
-            <a:schemeClr val="accent1"/>
-          </a:lnRef>
-          <a:fillRef idx="3">
-            <a:schemeClr val="accent1"/>
-          </a:fillRef>
-          <a:effectRef idx="2">
-            <a:schemeClr val="accent1"/>
-          </a:effectRef>
-          <a:fontRef idx="minor">
-            <a:schemeClr val="lt1"/>
-          </a:fontRef>
-        </p:style>
-        <p:txBody>
-          <a:bodyPr rtlCol="0" anchor="ctr"/>
-          <a:lstStyle/>
-          <a:p>
-            <a:pPr algn="ctr"/>
-          </a:p>
-        </p:txBody>
-      </p:sp>
-      <p:sp>
-        <p:nvSpPr>
-          <p:cNvPr id="31" name="Oval 30"/>
-          <p:cNvSpPr/>
-          <p:nvPr/>
-        </p:nvSpPr>
-        <p:spPr>
-          <a:xfrm>
-            <a:off x="5815012" y="3200400"/>
-            <a:ext cx="91440" cy="109728"/>
-          </a:xfrm>
-          <a:prstGeom prst="ellipse">
-            <a:avLst/>
-          </a:prstGeom>
-          <a:solidFill>
-            <a:srgbClr val="7E6849"/>
-          </a:solidFill>
-          <a:ln>
-            <a:noFill/>
-          </a:ln>
-        </p:spPr>
-        <p:style>
-          <a:lnRef idx="1">
-            <a:schemeClr val="accent1"/>
-          </a:lnRef>
-          <a:fillRef idx="3">
-            <a:schemeClr val="accent1"/>
-          </a:fillRef>
-          <a:effectRef idx="2">
-            <a:schemeClr val="accent1"/>
-          </a:effectRef>
-          <a:fontRef idx="minor">
-            <a:schemeClr val="lt1"/>
-          </a:fontRef>
-        </p:style>
-        <p:txBody>
-          <a:bodyPr rtlCol="0" anchor="ctr"/>
-          <a:lstStyle/>
-          <a:p>
-            <a:pPr algn="ctr"/>
-          </a:p>
-        </p:txBody>
-      </p:sp>
-      <p:sp>
-        <p:nvSpPr>
-          <p:cNvPr id="32" name="TextBox 31"/>
-          <p:cNvSpPr txBox="1"/>
-          <p:nvPr/>
-        </p:nvSpPr>
-        <p:spPr>
-          <a:xfrm>
-            <a:off x="5906452" y="3182112"/>
-            <a:ext cx="411480" cy="182880"/>
-          </a:xfrm>
-          <a:prstGeom prst="rect">
-            <a:avLst/>
-          </a:prstGeom>
-          <a:noFill/>
-        </p:spPr>
-        <p:txBody>
-          <a:bodyPr wrap="square" lIns="0" rIns="0" tIns="0" bIns="0" anchor="t">
-            <a:spAutoFit/>
-          </a:bodyPr>
-          <a:lstStyle/>
-          <a:p>
-            <a:pPr algn="l"/>
-            <a:r>
-              <a:rPr sz="1000" b="0">
-                <a:solidFill>
-                  <a:srgbClr val="1A1A1A"/>
-                </a:solidFill>
-                <a:latin typeface="Calibri"/>
-              </a:rPr>
-              <a:t>22.3x</a:t>
-            </a:r>
-          </a:p>
-        </p:txBody>
-      </p:sp>
-      <p:sp>
-        <p:nvSpPr>
-          <p:cNvPr id="33" name="TextBox 32"/>
-          <p:cNvSpPr txBox="1"/>
-          <p:nvPr/>
-        </p:nvSpPr>
-        <p:spPr>
-          <a:xfrm>
-            <a:off x="3520440" y="3438144"/>
-            <a:ext cx="502920" cy="182880"/>
-          </a:xfrm>
-          <a:prstGeom prst="rect">
-            <a:avLst/>
-          </a:prstGeom>
-          <a:noFill/>
-        </p:spPr>
-        <p:txBody>
-          <a:bodyPr wrap="square" lIns="0" rIns="0" tIns="0" bIns="0" anchor="t">
-            <a:spAutoFit/>
-          </a:bodyPr>
-          <a:lstStyle/>
-          <a:p>
-            <a:pPr algn="l"/>
-            <a:r>
-              <a:rPr sz="1000" b="0">
-                <a:solidFill>
-                  <a:srgbClr val="1A1A1A"/>
-                </a:solidFill>
-                <a:latin typeface="Calibri"/>
-              </a:rPr>
-              <a:t>FY2026</a:t>
-            </a:r>
-          </a:p>
-        </p:txBody>
-      </p:sp>
-      <p:sp>
-        <p:nvSpPr>
-          <p:cNvPr id="34" name="Rectangle 33"/>
-          <p:cNvSpPr/>
-          <p:nvPr/>
-        </p:nvSpPr>
-        <p:spPr>
-          <a:xfrm>
-            <a:off x="4023360" y="3493008"/>
-            <a:ext cx="822959" cy="73152"/>
-          </a:xfrm>
-          <a:prstGeom prst="rect">
-            <a:avLst/>
-          </a:prstGeom>
-          <a:solidFill>
-            <a:srgbClr val="EFE8DC"/>
-          </a:solidFill>
-          <a:ln>
-            <a:noFill/>
-          </a:ln>
-        </p:spPr>
-        <p:style>
-          <a:lnRef idx="1">
-            <a:schemeClr val="accent1"/>
-          </a:lnRef>
-          <a:fillRef idx="3">
-            <a:schemeClr val="accent1"/>
-          </a:fillRef>
-          <a:effectRef idx="2">
-            <a:schemeClr val="accent1"/>
-          </a:effectRef>
-          <a:fontRef idx="minor">
-            <a:schemeClr val="lt1"/>
-          </a:fontRef>
-        </p:style>
-        <p:txBody>
-          <a:bodyPr rtlCol="0" anchor="ctr"/>
-          <a:lstStyle/>
-          <a:p>
-            <a:pPr algn="ctr"/>
-          </a:p>
-        </p:txBody>
-      </p:sp>
-      <p:sp>
-        <p:nvSpPr>
-          <p:cNvPr id="35" name="Oval 34"/>
-          <p:cNvSpPr/>
-          <p:nvPr/>
-        </p:nvSpPr>
-        <p:spPr>
-          <a:xfrm>
-            <a:off x="4800600" y="3474720"/>
-            <a:ext cx="91440" cy="109728"/>
-          </a:xfrm>
-          <a:prstGeom prst="ellipse">
-            <a:avLst/>
-          </a:prstGeom>
-          <a:solidFill>
-            <a:srgbClr val="7E6849"/>
-          </a:solidFill>
-          <a:ln>
-            <a:noFill/>
-          </a:ln>
-        </p:spPr>
-        <p:style>
-          <a:lnRef idx="1">
-            <a:schemeClr val="accent1"/>
-          </a:lnRef>
-          <a:fillRef idx="3">
-            <a:schemeClr val="accent1"/>
-          </a:fillRef>
-          <a:effectRef idx="2">
-            <a:schemeClr val="accent1"/>
-          </a:effectRef>
-          <a:fontRef idx="minor">
-            <a:schemeClr val="lt1"/>
-          </a:fontRef>
-        </p:style>
-        <p:txBody>
-          <a:bodyPr rtlCol="0" anchor="ctr"/>
-          <a:lstStyle/>
-          <a:p>
-            <a:pPr algn="ctr"/>
-          </a:p>
-        </p:txBody>
-      </p:sp>
-      <p:sp>
-        <p:nvSpPr>
-          <p:cNvPr id="36" name="TextBox 35"/>
-          <p:cNvSpPr txBox="1"/>
-          <p:nvPr/>
-        </p:nvSpPr>
-        <p:spPr>
-          <a:xfrm>
-            <a:off x="4892040" y="3456432"/>
-            <a:ext cx="411480" cy="182880"/>
-          </a:xfrm>
-          <a:prstGeom prst="rect">
-            <a:avLst/>
-          </a:prstGeom>
-          <a:noFill/>
-        </p:spPr>
-        <p:txBody>
-          <a:bodyPr wrap="square" lIns="0" rIns="0" tIns="0" bIns="0" anchor="t">
-            <a:spAutoFit/>
-          </a:bodyPr>
-          <a:lstStyle/>
-          <a:p>
-            <a:pPr algn="l"/>
-            <a:r>
-              <a:rPr sz="1000" b="0">
-                <a:solidFill>
-                  <a:srgbClr val="1A1A1A"/>
-                </a:solidFill>
-                <a:latin typeface="Calibri"/>
-              </a:rPr>
-              <a:t>15.2x</a:t>
-            </a:r>
-          </a:p>
-        </p:txBody>
-      </p:sp>
-      <p:sp>
-        <p:nvSpPr>
-          <p:cNvPr id="37" name="TextBox 36"/>
-          <p:cNvSpPr txBox="1"/>
-          <p:nvPr/>
-        </p:nvSpPr>
-        <p:spPr>
-          <a:xfrm>
-            <a:off x="3520440" y="3712463"/>
-            <a:ext cx="502920" cy="182880"/>
-          </a:xfrm>
-          <a:prstGeom prst="rect">
-            <a:avLst/>
-          </a:prstGeom>
-          <a:noFill/>
-        </p:spPr>
-        <p:txBody>
-          <a:bodyPr wrap="square" lIns="0" rIns="0" tIns="0" bIns="0" anchor="t">
-            <a:spAutoFit/>
-          </a:bodyPr>
-          <a:lstStyle/>
-          <a:p>
-            <a:pPr algn="l"/>
-            <a:r>
-              <a:rPr sz="1000" b="0">
-                <a:solidFill>
-                  <a:srgbClr val="1A1A1A"/>
-                </a:solidFill>
-                <a:latin typeface="Calibri"/>
-              </a:rPr>
-              <a:t>FY2027</a:t>
-            </a:r>
-          </a:p>
-        </p:txBody>
-      </p:sp>
-      <p:sp>
-        <p:nvSpPr>
-          <p:cNvPr id="38" name="Rectangle 37"/>
-          <p:cNvSpPr/>
-          <p:nvPr/>
-        </p:nvSpPr>
-        <p:spPr>
-          <a:xfrm>
-            <a:off x="4023360" y="3767327"/>
-            <a:ext cx="551497" cy="73152"/>
-          </a:xfrm>
-          <a:prstGeom prst="rect">
-            <a:avLst/>
-          </a:prstGeom>
-          <a:solidFill>
-            <a:srgbClr val="EFE8DC"/>
-          </a:solidFill>
-          <a:ln>
-            <a:noFill/>
-          </a:ln>
-        </p:spPr>
-        <p:style>
-          <a:lnRef idx="1">
-            <a:schemeClr val="accent1"/>
-          </a:lnRef>
-          <a:fillRef idx="3">
-            <a:schemeClr val="accent1"/>
-          </a:fillRef>
-          <a:effectRef idx="2">
-            <a:schemeClr val="accent1"/>
-          </a:effectRef>
-          <a:fontRef idx="minor">
-            <a:schemeClr val="lt1"/>
-          </a:fontRef>
-        </p:style>
-        <p:txBody>
-          <a:bodyPr rtlCol="0" anchor="ctr"/>
-          <a:lstStyle/>
-          <a:p>
-            <a:pPr algn="ctr"/>
-          </a:p>
-        </p:txBody>
-      </p:sp>
-      <p:sp>
-        <p:nvSpPr>
-          <p:cNvPr id="39" name="Oval 38"/>
-          <p:cNvSpPr/>
-          <p:nvPr/>
-        </p:nvSpPr>
-        <p:spPr>
-          <a:xfrm>
-            <a:off x="4529137" y="3749039"/>
-            <a:ext cx="91440" cy="109728"/>
-          </a:xfrm>
-          <a:prstGeom prst="ellipse">
-            <a:avLst/>
-          </a:prstGeom>
-          <a:solidFill>
-            <a:srgbClr val="7E6849"/>
-          </a:solidFill>
-          <a:ln>
-            <a:noFill/>
-          </a:ln>
-        </p:spPr>
-        <p:style>
-          <a:lnRef idx="1">
-            <a:schemeClr val="accent1"/>
-          </a:lnRef>
-          <a:fillRef idx="3">
-            <a:schemeClr val="accent1"/>
-          </a:fillRef>
-          <a:effectRef idx="2">
-            <a:schemeClr val="accent1"/>
-          </a:effectRef>
-          <a:fontRef idx="minor">
-            <a:schemeClr val="lt1"/>
-          </a:fontRef>
-        </p:style>
-        <p:txBody>
-          <a:bodyPr rtlCol="0" anchor="ctr"/>
-          <a:lstStyle/>
-          <a:p>
-            <a:pPr algn="ctr"/>
-          </a:p>
-        </p:txBody>
-      </p:sp>
-      <p:sp>
-        <p:nvSpPr>
-          <p:cNvPr id="40" name="TextBox 39"/>
-          <p:cNvSpPr txBox="1"/>
-          <p:nvPr/>
-        </p:nvSpPr>
-        <p:spPr>
-          <a:xfrm>
-            <a:off x="4620577" y="3730751"/>
-            <a:ext cx="411480" cy="182880"/>
-          </a:xfrm>
-          <a:prstGeom prst="rect">
-            <a:avLst/>
-          </a:prstGeom>
-          <a:noFill/>
-        </p:spPr>
-        <p:txBody>
-          <a:bodyPr wrap="square" lIns="0" rIns="0" tIns="0" bIns="0" anchor="t">
-            <a:spAutoFit/>
-          </a:bodyPr>
-          <a:lstStyle/>
-          <a:p>
-            <a:pPr algn="l"/>
-            <a:r>
-              <a:rPr sz="1000" b="0">
-                <a:solidFill>
-                  <a:srgbClr val="1A1A1A"/>
-                </a:solidFill>
-                <a:latin typeface="Calibri"/>
-              </a:rPr>
-              <a:t>13.3x</a:t>
-            </a:r>
-          </a:p>
-        </p:txBody>
-      </p:sp>
-      <p:sp>
-        <p:nvSpPr>
-          <p:cNvPr id="41" name="TextBox 40"/>
-          <p:cNvSpPr txBox="1"/>
-          <p:nvPr/>
-        </p:nvSpPr>
-        <p:spPr>
-          <a:xfrm>
-            <a:off x="3520440" y="3986783"/>
-            <a:ext cx="502920" cy="182880"/>
-          </a:xfrm>
-          <a:prstGeom prst="rect">
-            <a:avLst/>
-          </a:prstGeom>
-          <a:noFill/>
-        </p:spPr>
-        <p:txBody>
-          <a:bodyPr wrap="square" lIns="0" rIns="0" tIns="0" bIns="0" anchor="t">
-            <a:spAutoFit/>
-          </a:bodyPr>
-          <a:lstStyle/>
-          <a:p>
-            <a:pPr algn="l"/>
-            <a:r>
-              <a:rPr sz="1000" b="0">
-                <a:solidFill>
-                  <a:srgbClr val="1A1A1A"/>
-                </a:solidFill>
-                <a:latin typeface="Calibri"/>
-              </a:rPr>
-              <a:t>FY2028</a:t>
-            </a:r>
-          </a:p>
-        </p:txBody>
-      </p:sp>
-      <p:sp>
-        <p:nvSpPr>
-          <p:cNvPr id="42" name="Rectangle 41"/>
-          <p:cNvSpPr/>
-          <p:nvPr/>
-        </p:nvSpPr>
-        <p:spPr>
-          <a:xfrm>
-            <a:off x="4023360" y="4041647"/>
-            <a:ext cx="337184" cy="73152"/>
-          </a:xfrm>
-          <a:prstGeom prst="rect">
-            <a:avLst/>
-          </a:prstGeom>
-          <a:solidFill>
-            <a:srgbClr val="EFE8DC"/>
-          </a:solidFill>
-          <a:ln>
-            <a:noFill/>
-          </a:ln>
-        </p:spPr>
-        <p:style>
-          <a:lnRef idx="1">
-            <a:schemeClr val="accent1"/>
-          </a:lnRef>
-          <a:fillRef idx="3">
-            <a:schemeClr val="accent1"/>
-          </a:fillRef>
-          <a:effectRef idx="2">
-            <a:schemeClr val="accent1"/>
-          </a:effectRef>
-          <a:fontRef idx="minor">
-            <a:schemeClr val="lt1"/>
-          </a:fontRef>
-        </p:style>
-        <p:txBody>
-          <a:bodyPr rtlCol="0" anchor="ctr"/>
-          <a:lstStyle/>
-          <a:p>
-            <a:pPr algn="ctr"/>
-          </a:p>
-        </p:txBody>
-      </p:sp>
-      <p:sp>
-        <p:nvSpPr>
-          <p:cNvPr id="43" name="Oval 42"/>
-          <p:cNvSpPr/>
-          <p:nvPr/>
-        </p:nvSpPr>
-        <p:spPr>
-          <a:xfrm>
-            <a:off x="4314825" y="4023359"/>
-            <a:ext cx="91440" cy="109728"/>
-          </a:xfrm>
-          <a:prstGeom prst="ellipse">
-            <a:avLst/>
-          </a:prstGeom>
-          <a:solidFill>
-            <a:srgbClr val="7E6849"/>
-          </a:solidFill>
-          <a:ln>
-            <a:noFill/>
-          </a:ln>
-        </p:spPr>
-        <p:style>
-          <a:lnRef idx="1">
-            <a:schemeClr val="accent1"/>
-          </a:lnRef>
-          <a:fillRef idx="3">
-            <a:schemeClr val="accent1"/>
-          </a:fillRef>
-          <a:effectRef idx="2">
-            <a:schemeClr val="accent1"/>
-          </a:effectRef>
-          <a:fontRef idx="minor">
-            <a:schemeClr val="lt1"/>
-          </a:fontRef>
-        </p:style>
-        <p:txBody>
-          <a:bodyPr rtlCol="0" anchor="ctr"/>
-          <a:lstStyle/>
-          <a:p>
-            <a:pPr algn="ctr"/>
-          </a:p>
-        </p:txBody>
-      </p:sp>
-      <p:sp>
-        <p:nvSpPr>
-          <p:cNvPr id="44" name="TextBox 43"/>
-          <p:cNvSpPr txBox="1"/>
-          <p:nvPr/>
-        </p:nvSpPr>
-        <p:spPr>
-          <a:xfrm>
-            <a:off x="4406265" y="4005071"/>
-            <a:ext cx="411480" cy="182880"/>
-          </a:xfrm>
-          <a:prstGeom prst="rect">
-            <a:avLst/>
-          </a:prstGeom>
-          <a:noFill/>
-        </p:spPr>
-        <p:txBody>
-          <a:bodyPr wrap="square" lIns="0" rIns="0" tIns="0" bIns="0" anchor="t">
-            <a:spAutoFit/>
-          </a:bodyPr>
-          <a:lstStyle/>
-          <a:p>
-            <a:pPr algn="l"/>
-            <a:r>
-              <a:rPr sz="1000" b="0">
-                <a:solidFill>
-                  <a:srgbClr val="1A1A1A"/>
-                </a:solidFill>
-                <a:latin typeface="Calibri"/>
-              </a:rPr>
-              <a:t>11.8x</a:t>
-            </a:r>
-          </a:p>
-        </p:txBody>
-      </p:sp>
-      <p:sp>
-        <p:nvSpPr>
-          <p:cNvPr id="45" name="TextBox 44"/>
-          <p:cNvSpPr txBox="1"/>
-          <p:nvPr/>
-        </p:nvSpPr>
-        <p:spPr>
-          <a:xfrm>
-            <a:off x="3886200" y="4297680"/>
-            <a:ext cx="365760" cy="164592"/>
-          </a:xfrm>
-          <a:prstGeom prst="rect">
-            <a:avLst/>
-          </a:prstGeom>
-          <a:noFill/>
-        </p:spPr>
-        <p:txBody>
-          <a:bodyPr wrap="square" lIns="0" rIns="0" tIns="0" bIns="0" anchor="t">
-            <a:spAutoFit/>
-          </a:bodyPr>
-          <a:lstStyle/>
-          <a:p>
-            <a:pPr algn="l"/>
-            <a:r>
-              <a:rPr sz="700" b="0">
-                <a:solidFill>
-                  <a:srgbClr val="9A9A9A"/>
-                </a:solidFill>
-                <a:latin typeface="Calibri"/>
-              </a:rPr>
-              <a:t>9x</a:t>
-            </a:r>
-          </a:p>
-        </p:txBody>
-      </p:sp>
-      <p:sp>
-        <p:nvSpPr>
-          <p:cNvPr id="46" name="TextBox 45"/>
-          <p:cNvSpPr txBox="1"/>
-          <p:nvPr/>
-        </p:nvSpPr>
-        <p:spPr>
-          <a:xfrm>
-            <a:off x="4663440" y="4297680"/>
-            <a:ext cx="365760" cy="164592"/>
-          </a:xfrm>
-          <a:prstGeom prst="rect">
-            <a:avLst/>
-          </a:prstGeom>
-          <a:noFill/>
-        </p:spPr>
-        <p:txBody>
-          <a:bodyPr wrap="square" lIns="0" rIns="0" tIns="0" bIns="0" anchor="t">
-            <a:spAutoFit/>
-          </a:bodyPr>
-          <a:lstStyle/>
-          <a:p>
-            <a:pPr algn="l"/>
-            <a:r>
-              <a:rPr sz="700" b="0">
-                <a:solidFill>
-                  <a:srgbClr val="9A9A9A"/>
-                </a:solidFill>
-                <a:latin typeface="Calibri"/>
-              </a:rPr>
-              <a:t>15x</a:t>
-            </a:r>
-          </a:p>
-        </p:txBody>
-      </p:sp>
-      <p:sp>
-        <p:nvSpPr>
-          <p:cNvPr id="47" name="TextBox 46"/>
-          <p:cNvSpPr txBox="1"/>
-          <p:nvPr/>
-        </p:nvSpPr>
-        <p:spPr>
-          <a:xfrm>
-            <a:off x="5440679" y="4297680"/>
-            <a:ext cx="365760" cy="164592"/>
-          </a:xfrm>
-          <a:prstGeom prst="rect">
-            <a:avLst/>
-          </a:prstGeom>
-          <a:noFill/>
-        </p:spPr>
-        <p:txBody>
-          <a:bodyPr wrap="square" lIns="0" rIns="0" tIns="0" bIns="0" anchor="t">
-            <a:spAutoFit/>
-          </a:bodyPr>
-          <a:lstStyle/>
-          <a:p>
-            <a:pPr algn="l"/>
-            <a:r>
-              <a:rPr sz="700" b="0">
-                <a:solidFill>
-                  <a:srgbClr val="9A9A9A"/>
-                </a:solidFill>
-                <a:latin typeface="Calibri"/>
-              </a:rPr>
-              <a:t>20x</a:t>
-            </a:r>
-          </a:p>
-        </p:txBody>
-      </p:sp>
-      <p:sp>
-        <p:nvSpPr>
-          <p:cNvPr id="48" name="TextBox 47"/>
-          <p:cNvSpPr txBox="1"/>
-          <p:nvPr/>
-        </p:nvSpPr>
-        <p:spPr>
-          <a:xfrm>
-            <a:off x="6217920" y="4297680"/>
-            <a:ext cx="365760" cy="164592"/>
-          </a:xfrm>
-          <a:prstGeom prst="rect">
-            <a:avLst/>
-          </a:prstGeom>
-          <a:noFill/>
-        </p:spPr>
-        <p:txBody>
-          <a:bodyPr wrap="square" lIns="0" rIns="0" tIns="0" bIns="0" anchor="t">
-            <a:spAutoFit/>
-          </a:bodyPr>
-          <a:lstStyle/>
-          <a:p>
-            <a:pPr algn="l"/>
-            <a:r>
-              <a:rPr sz="700" b="0">
-                <a:solidFill>
-                  <a:srgbClr val="9A9A9A"/>
-                </a:solidFill>
-                <a:latin typeface="Calibri"/>
-              </a:rPr>
-              <a:t>26x</a:t>
-            </a:r>
-          </a:p>
-        </p:txBody>
-      </p:sp>
-      <p:sp>
-        <p:nvSpPr>
-          <p:cNvPr id="49" name="Diamond 48"/>
-          <p:cNvSpPr/>
-          <p:nvPr/>
-        </p:nvSpPr>
-        <p:spPr>
-          <a:xfrm>
-            <a:off x="4287393" y="4242816"/>
+            <a:off x="5282619" y="2322575"/>
             <a:ext cx="146304" cy="146304"/>
           </a:xfrm>
           <a:prstGeom prst="diamond">
@@ -11355,13 +10263,13 @@
       </p:sp>
       <p:sp>
         <p:nvSpPr>
-          <p:cNvPr id="50" name="TextBox 49"/>
-          <p:cNvSpPr txBox="1"/>
-          <p:nvPr/>
-        </p:nvSpPr>
-        <p:spPr>
-          <a:xfrm>
-            <a:off x="4451985" y="4224528"/>
+          <p:cNvPr id="22" name="TextBox 21"/>
+          <p:cNvSpPr txBox="1"/>
+          <p:nvPr/>
+        </p:nvSpPr>
+        <p:spPr>
+          <a:xfrm>
+            <a:off x="5447211" y="2304287"/>
             <a:ext cx="1280160" cy="164592"/>
           </a:xfrm>
           <a:prstGeom prst="rect">
@@ -11383,14 +10291,14 @@
                 </a:solidFill>
                 <a:latin typeface="Calibri"/>
               </a:rPr>
-              <a:t>Current  (11.8x)</a:t>
-            </a:r>
-          </a:p>
-        </p:txBody>
-      </p:sp>
-      <p:sp>
-        <p:nvSpPr>
-          <p:cNvPr id="51" name="Rectangle 50"/>
+              <a:t>Current  (15.1x)</a:t>
+            </a:r>
+          </a:p>
+        </p:txBody>
+      </p:sp>
+      <p:sp>
+        <p:nvSpPr>
+          <p:cNvPr id="23" name="Rectangle 22"/>
           <p:cNvSpPr/>
           <p:nvPr/>
         </p:nvSpPr>
@@ -11434,7 +10342,7 @@
       </p:sp>
       <p:sp>
         <p:nvSpPr>
-          <p:cNvPr id="52" name="TextBox 51"/>
+          <p:cNvPr id="24" name="TextBox 23"/>
           <p:cNvSpPr txBox="1"/>
           <p:nvPr/>
         </p:nvSpPr>
@@ -11462,14 +10370,14 @@
                 </a:solidFill>
                 <a:latin typeface="Calibri"/>
               </a:rPr>
-              <a:t>PEER COMPARABLES  ·  SELECTED GLOBAL PEERS</a:t>
-            </a:r>
-          </a:p>
-        </p:txBody>
-      </p:sp>
-      <p:sp>
-        <p:nvSpPr>
-          <p:cNvPr id="53" name="TextBox 52"/>
+              <a:t>PEER COMPARABLES  ·  CHINA/HK INTERNET PEERS</a:t>
+            </a:r>
+          </a:p>
+        </p:txBody>
+      </p:sp>
+      <p:sp>
+        <p:nvSpPr>
+          <p:cNvPr id="25" name="TextBox 24"/>
           <p:cNvSpPr txBox="1"/>
           <p:nvPr/>
         </p:nvSpPr>
@@ -11504,7 +10412,7 @@
       </p:sp>
       <p:sp>
         <p:nvSpPr>
-          <p:cNvPr id="54" name="TextBox 53"/>
+          <p:cNvPr id="26" name="TextBox 25"/>
           <p:cNvSpPr txBox="1"/>
           <p:nvPr/>
         </p:nvSpPr>
@@ -11539,7 +10447,7 @@
       </p:sp>
       <p:sp>
         <p:nvSpPr>
-          <p:cNvPr id="55" name="TextBox 54"/>
+          <p:cNvPr id="27" name="TextBox 26"/>
           <p:cNvSpPr txBox="1"/>
           <p:nvPr/>
         </p:nvSpPr>
@@ -11574,7 +10482,7 @@
       </p:sp>
       <p:sp>
         <p:nvSpPr>
-          <p:cNvPr id="56" name="TextBox 55"/>
+          <p:cNvPr id="28" name="TextBox 27"/>
           <p:cNvSpPr txBox="1"/>
           <p:nvPr/>
         </p:nvSpPr>
@@ -11609,7 +10517,7 @@
       </p:sp>
       <p:sp>
         <p:nvSpPr>
-          <p:cNvPr id="57" name="TextBox 56"/>
+          <p:cNvPr id="29" name="TextBox 28"/>
           <p:cNvSpPr txBox="1"/>
           <p:nvPr/>
         </p:nvSpPr>
@@ -11644,7 +10552,7 @@
       </p:sp>
       <p:sp>
         <p:nvSpPr>
-          <p:cNvPr id="58" name="TextBox 57"/>
+          <p:cNvPr id="30" name="TextBox 29"/>
           <p:cNvSpPr txBox="1"/>
           <p:nvPr/>
         </p:nvSpPr>
@@ -11679,7 +10587,7 @@
       </p:sp>
       <p:sp>
         <p:nvSpPr>
-          <p:cNvPr id="59" name="Rectangle 58"/>
+          <p:cNvPr id="31" name="Rectangle 30"/>
           <p:cNvSpPr/>
           <p:nvPr/>
         </p:nvSpPr>
@@ -11723,217 +10631,7 @@
       </p:sp>
       <p:sp>
         <p:nvSpPr>
-          <p:cNvPr id="60" name="TextBox 59"/>
-          <p:cNvSpPr txBox="1"/>
-          <p:nvPr/>
-        </p:nvSpPr>
-        <p:spPr>
-          <a:xfrm>
-            <a:off x="411480" y="5093208"/>
-            <a:ext cx="1874520" cy="256032"/>
-          </a:xfrm>
-          <a:prstGeom prst="rect">
-            <a:avLst/>
-          </a:prstGeom>
-          <a:noFill/>
-        </p:spPr>
-        <p:txBody>
-          <a:bodyPr wrap="square" lIns="0" rIns="0" tIns="0" bIns="0" anchor="t">
-            <a:spAutoFit/>
-          </a:bodyPr>
-          <a:lstStyle/>
-          <a:p>
-            <a:pPr algn="l"/>
-            <a:r>
-              <a:rPr sz="1000" b="0">
-                <a:solidFill>
-                  <a:srgbClr val="1A1A1A"/>
-                </a:solidFill>
-                <a:latin typeface="Calibri"/>
-              </a:rPr>
-              <a:t>iShares MSCI China ETF</a:t>
-            </a:r>
-          </a:p>
-        </p:txBody>
-      </p:sp>
-      <p:sp>
-        <p:nvSpPr>
-          <p:cNvPr id="61" name="TextBox 60"/>
-          <p:cNvSpPr txBox="1"/>
-          <p:nvPr/>
-        </p:nvSpPr>
-        <p:spPr>
-          <a:xfrm>
-            <a:off x="2331720" y="5093208"/>
-            <a:ext cx="960120" cy="256032"/>
-          </a:xfrm>
-          <a:prstGeom prst="rect">
-            <a:avLst/>
-          </a:prstGeom>
-          <a:noFill/>
-        </p:spPr>
-        <p:txBody>
-          <a:bodyPr wrap="square" lIns="0" rIns="0" tIns="0" bIns="0" anchor="t">
-            <a:spAutoFit/>
-          </a:bodyPr>
-          <a:lstStyle/>
-          <a:p>
-            <a:pPr algn="l"/>
-            <a:r>
-              <a:rPr sz="1000" b="0">
-                <a:solidFill>
-                  <a:srgbClr val="1A1A1A"/>
-                </a:solidFill>
-                <a:latin typeface="Calibri"/>
-              </a:rPr>
-              <a:t>MCHI</a:t>
-            </a:r>
-          </a:p>
-        </p:txBody>
-      </p:sp>
-      <p:sp>
-        <p:nvSpPr>
-          <p:cNvPr id="62" name="TextBox 61"/>
-          <p:cNvSpPr txBox="1"/>
-          <p:nvPr/>
-        </p:nvSpPr>
-        <p:spPr>
-          <a:xfrm>
-            <a:off x="3337560" y="5093208"/>
-            <a:ext cx="960120" cy="256032"/>
-          </a:xfrm>
-          <a:prstGeom prst="rect">
-            <a:avLst/>
-          </a:prstGeom>
-          <a:noFill/>
-        </p:spPr>
-        <p:txBody>
-          <a:bodyPr wrap="square" lIns="0" rIns="0" tIns="0" bIns="0" anchor="t">
-            <a:spAutoFit/>
-          </a:bodyPr>
-          <a:lstStyle/>
-          <a:p>
-            <a:pPr algn="r"/>
-            <a:r>
-              <a:rPr sz="1000" b="0">
-                <a:solidFill>
-                  <a:srgbClr val="1A1A1A"/>
-                </a:solidFill>
-                <a:latin typeface="Calibri"/>
-              </a:rPr>
-              <a:t>$6.6B</a:t>
-            </a:r>
-          </a:p>
-        </p:txBody>
-      </p:sp>
-      <p:sp>
-        <p:nvSpPr>
-          <p:cNvPr id="63" name="TextBox 62"/>
-          <p:cNvSpPr txBox="1"/>
-          <p:nvPr/>
-        </p:nvSpPr>
-        <p:spPr>
-          <a:xfrm>
-            <a:off x="4343400" y="5093208"/>
-            <a:ext cx="594359" cy="256032"/>
-          </a:xfrm>
-          <a:prstGeom prst="rect">
-            <a:avLst/>
-          </a:prstGeom>
-          <a:noFill/>
-        </p:spPr>
-        <p:txBody>
-          <a:bodyPr wrap="square" lIns="0" rIns="0" tIns="0" bIns="0" anchor="t">
-            <a:spAutoFit/>
-          </a:bodyPr>
-          <a:lstStyle/>
-          <a:p>
-            <a:pPr algn="r"/>
-            <a:r>
-              <a:rPr sz="1000" b="0">
-                <a:solidFill>
-                  <a:srgbClr val="1A1A1A"/>
-                </a:solidFill>
-                <a:latin typeface="Calibri"/>
-              </a:rPr>
-              <a:t>—</a:t>
-            </a:r>
-          </a:p>
-        </p:txBody>
-      </p:sp>
-      <p:sp>
-        <p:nvSpPr>
-          <p:cNvPr id="64" name="TextBox 63"/>
-          <p:cNvSpPr txBox="1"/>
-          <p:nvPr/>
-        </p:nvSpPr>
-        <p:spPr>
-          <a:xfrm>
-            <a:off x="4983480" y="5093208"/>
-            <a:ext cx="685800" cy="256032"/>
-          </a:xfrm>
-          <a:prstGeom prst="rect">
-            <a:avLst/>
-          </a:prstGeom>
-          <a:noFill/>
-        </p:spPr>
-        <p:txBody>
-          <a:bodyPr wrap="square" lIns="0" rIns="0" tIns="0" bIns="0" anchor="t">
-            <a:spAutoFit/>
-          </a:bodyPr>
-          <a:lstStyle/>
-          <a:p>
-            <a:pPr algn="r"/>
-            <a:r>
-              <a:rPr sz="1000" b="0">
-                <a:solidFill>
-                  <a:srgbClr val="1A1A1A"/>
-                </a:solidFill>
-                <a:latin typeface="Calibri"/>
-              </a:rPr>
-              <a:t>+31.1% YTD</a:t>
-            </a:r>
-          </a:p>
-        </p:txBody>
-      </p:sp>
-      <p:sp>
-        <p:nvSpPr>
-          <p:cNvPr id="65" name="TextBox 64"/>
-          <p:cNvSpPr txBox="1"/>
-          <p:nvPr/>
-        </p:nvSpPr>
-        <p:spPr>
-          <a:xfrm>
-            <a:off x="5715000" y="5093208"/>
-            <a:ext cx="685800" cy="256032"/>
-          </a:xfrm>
-          <a:prstGeom prst="rect">
-            <a:avLst/>
-          </a:prstGeom>
-          <a:noFill/>
-        </p:spPr>
-        <p:txBody>
-          <a:bodyPr wrap="square" lIns="0" rIns="0" tIns="0" bIns="0" anchor="t">
-            <a:spAutoFit/>
-          </a:bodyPr>
-          <a:lstStyle/>
-          <a:p>
-            <a:pPr algn="r"/>
-            <a:r>
-              <a:rPr sz="1000" b="0">
-                <a:solidFill>
-                  <a:srgbClr val="2F7D4F"/>
-                </a:solidFill>
-                <a:latin typeface="Calibri"/>
-              </a:rPr>
-              <a:t>+4.8%</a:t>
-            </a:r>
-          </a:p>
-        </p:txBody>
-      </p:sp>
-      <p:sp>
-        <p:nvSpPr>
-          <p:cNvPr id="66" name="Rectangle 65"/>
+          <p:cNvPr id="32" name="Rectangle 31"/>
           <p:cNvSpPr/>
           <p:nvPr/>
         </p:nvSpPr>
@@ -11977,7 +10675,7 @@
       </p:sp>
       <p:sp>
         <p:nvSpPr>
-          <p:cNvPr id="67" name="TextBox 66"/>
+          <p:cNvPr id="33" name="TextBox 32"/>
           <p:cNvSpPr txBox="1"/>
           <p:nvPr/>
         </p:nvSpPr>
@@ -12012,7 +10710,7 @@
       </p:sp>
       <p:sp>
         <p:nvSpPr>
-          <p:cNvPr id="68" name="Rectangle 67"/>
+          <p:cNvPr id="34" name="Rectangle 33"/>
           <p:cNvSpPr/>
           <p:nvPr/>
         </p:nvSpPr>
@@ -12058,7 +10756,7 @@
       </p:sp>
       <p:sp>
         <p:nvSpPr>
-          <p:cNvPr id="69" name="Rectangle 68"/>
+          <p:cNvPr id="35" name="Rectangle 34"/>
           <p:cNvSpPr/>
           <p:nvPr/>
         </p:nvSpPr>
@@ -12102,7 +10800,7 @@
       </p:sp>
       <p:sp>
         <p:nvSpPr>
-          <p:cNvPr id="70" name="TextBox 69"/>
+          <p:cNvPr id="36" name="TextBox 35"/>
           <p:cNvSpPr txBox="1"/>
           <p:nvPr/>
         </p:nvSpPr>
@@ -12137,7 +10835,7 @@
       </p:sp>
       <p:sp>
         <p:nvSpPr>
-          <p:cNvPr id="71" name="Rectangle 70"/>
+          <p:cNvPr id="37" name="Rectangle 36"/>
           <p:cNvSpPr/>
           <p:nvPr/>
         </p:nvSpPr>
@@ -12180,7 +10878,7 @@
       </p:sp>
       <p:sp>
         <p:nvSpPr>
-          <p:cNvPr id="72" name="Rectangle 71"/>
+          <p:cNvPr id="38" name="Rectangle 37"/>
           <p:cNvSpPr/>
           <p:nvPr/>
         </p:nvSpPr>
@@ -12223,7 +10921,7 @@
       </p:sp>
       <p:sp>
         <p:nvSpPr>
-          <p:cNvPr id="73" name="Rectangle 72"/>
+          <p:cNvPr id="39" name="Rectangle 38"/>
           <p:cNvSpPr/>
           <p:nvPr/>
         </p:nvSpPr>
@@ -12266,7 +10964,7 @@
       </p:sp>
       <p:sp>
         <p:nvSpPr>
-          <p:cNvPr id="74" name="TextBox 73"/>
+          <p:cNvPr id="40" name="TextBox 39"/>
           <p:cNvSpPr txBox="1"/>
           <p:nvPr/>
         </p:nvSpPr>
@@ -12301,7 +10999,7 @@
       </p:sp>
       <p:sp>
         <p:nvSpPr>
-          <p:cNvPr id="75" name="TextBox 74"/>
+          <p:cNvPr id="41" name="TextBox 40"/>
           <p:cNvSpPr txBox="1"/>
           <p:nvPr/>
         </p:nvSpPr>
@@ -12336,7 +11034,7 @@
       </p:sp>
       <p:sp>
         <p:nvSpPr>
-          <p:cNvPr id="76" name="Rectangle 75"/>
+          <p:cNvPr id="42" name="Rectangle 41"/>
           <p:cNvSpPr/>
           <p:nvPr/>
         </p:nvSpPr>
@@ -12382,7 +11080,7 @@
       </p:sp>
       <p:sp>
         <p:nvSpPr>
-          <p:cNvPr id="77" name="Rectangle 76"/>
+          <p:cNvPr id="43" name="Rectangle 42"/>
           <p:cNvSpPr/>
           <p:nvPr/>
         </p:nvSpPr>
@@ -12426,7 +11124,7 @@
       </p:sp>
       <p:sp>
         <p:nvSpPr>
-          <p:cNvPr id="78" name="TextBox 77"/>
+          <p:cNvPr id="44" name="TextBox 43"/>
           <p:cNvSpPr txBox="1"/>
           <p:nvPr/>
         </p:nvSpPr>
@@ -12461,7 +11159,7 @@
       </p:sp>
       <p:sp>
         <p:nvSpPr>
-          <p:cNvPr id="79" name="TextBox 78"/>
+          <p:cNvPr id="45" name="TextBox 44"/>
           <p:cNvSpPr txBox="1"/>
           <p:nvPr/>
         </p:nvSpPr>
@@ -12489,14 +11187,14 @@
                 </a:solidFill>
                 <a:latin typeface="Calibri"/>
               </a:rPr>
-              <a:t>CNY 725.47</a:t>
-            </a:r>
-          </a:p>
-        </p:txBody>
-      </p:sp>
-      <p:sp>
-        <p:nvSpPr>
-          <p:cNvPr id="80" name="TextBox 79"/>
+              <a:t>HKD 708.68</a:t>
+            </a:r>
+          </a:p>
+        </p:txBody>
+      </p:sp>
+      <p:sp>
+        <p:nvSpPr>
+          <p:cNvPr id="46" name="TextBox 45"/>
           <p:cNvSpPr txBox="1"/>
           <p:nvPr/>
         </p:nvSpPr>
@@ -12524,14 +11222,14 @@
                 </a:solidFill>
                 <a:latin typeface="Calibri"/>
               </a:rPr>
-              <a:t>Range  CNY 420 — 890</a:t>
-            </a:r>
-          </a:p>
-        </p:txBody>
-      </p:sp>
-      <p:sp>
-        <p:nvSpPr>
-          <p:cNvPr id="81" name="TextBox 80"/>
+              <a:t>Range  HKD 418 — 878</a:t>
+            </a:r>
+          </a:p>
+        </p:txBody>
+      </p:sp>
+      <p:sp>
+        <p:nvSpPr>
+          <p:cNvPr id="47" name="TextBox 46"/>
           <p:cNvSpPr txBox="1"/>
           <p:nvPr/>
         </p:nvSpPr>
@@ -12559,14 +11257,14 @@
                 </a:solidFill>
                 <a:latin typeface="Calibri"/>
               </a:rPr>
-              <a:t>Implied +58.7% vs last close</a:t>
-            </a:r>
-          </a:p>
-        </p:txBody>
-      </p:sp>
-      <p:sp>
-        <p:nvSpPr>
-          <p:cNvPr id="82" name="Rectangle 81"/>
+              <a:t>Implied +55.3% vs last close</a:t>
+            </a:r>
+          </a:p>
+        </p:txBody>
+      </p:sp>
+      <p:sp>
+        <p:nvSpPr>
+          <p:cNvPr id="48" name="Rectangle 47"/>
           <p:cNvSpPr/>
           <p:nvPr/>
         </p:nvSpPr>
@@ -12612,7 +11310,7 @@
       </p:sp>
       <p:sp>
         <p:nvSpPr>
-          <p:cNvPr id="83" name="Rectangle 82"/>
+          <p:cNvPr id="49" name="Rectangle 48"/>
           <p:cNvSpPr/>
           <p:nvPr/>
         </p:nvSpPr>
@@ -12656,7 +11354,7 @@
       </p:sp>
       <p:sp>
         <p:nvSpPr>
-          <p:cNvPr id="84" name="TextBox 83"/>
+          <p:cNvPr id="50" name="TextBox 49"/>
           <p:cNvSpPr txBox="1"/>
           <p:nvPr/>
         </p:nvSpPr>
@@ -12691,7 +11389,7 @@
       </p:sp>
       <p:sp>
         <p:nvSpPr>
-          <p:cNvPr id="85" name="TextBox 84"/>
+          <p:cNvPr id="51" name="TextBox 50"/>
           <p:cNvSpPr txBox="1"/>
           <p:nvPr/>
         </p:nvSpPr>
@@ -12719,14 +11417,14 @@
                 </a:solidFill>
                 <a:latin typeface="Calibri"/>
               </a:rPr>
-              <a:t>May. 08</a:t>
-            </a:r>
-          </a:p>
-        </p:txBody>
-      </p:sp>
-      <p:sp>
-        <p:nvSpPr>
-          <p:cNvPr id="86" name="TextBox 85"/>
+              <a:t>13 May 2026</a:t>
+            </a:r>
+          </a:p>
+        </p:txBody>
+      </p:sp>
+      <p:sp>
+        <p:nvSpPr>
+          <p:cNvPr id="52" name="TextBox 51"/>
           <p:cNvSpPr txBox="1"/>
           <p:nvPr/>
         </p:nvSpPr>
@@ -12754,14 +11452,14 @@
                 </a:solidFill>
                 <a:latin typeface="Calibri"/>
               </a:rPr>
-              <a:t>Zephirin Adjusts Tencent Holdings' Price Target to HK$420 from HK$480, Keeps at Strong Sell</a:t>
-            </a:r>
-          </a:p>
-        </p:txBody>
-      </p:sp>
-      <p:sp>
-        <p:nvSpPr>
-          <p:cNvPr id="87" name="TextBox 86"/>
+              <a:t>Tencent's Valuation Repair Path Hinges on AI Development -- Market Talk</a:t>
+            </a:r>
+          </a:p>
+        </p:txBody>
+      </p:sp>
+      <p:sp>
+        <p:nvSpPr>
+          <p:cNvPr id="53" name="TextBox 52"/>
           <p:cNvSpPr txBox="1"/>
           <p:nvPr/>
         </p:nvSpPr>
@@ -12789,14 +11487,14 @@
                 </a:solidFill>
                 <a:latin typeface="Calibri"/>
               </a:rPr>
-              <a:t>Apr. 02</a:t>
-            </a:r>
-          </a:p>
-        </p:txBody>
-      </p:sp>
-      <p:sp>
-        <p:nvSpPr>
-          <p:cNvPr id="88" name="TextBox 87"/>
+              <a:t>08 May 2026</a:t>
+            </a:r>
+          </a:p>
+        </p:txBody>
+      </p:sp>
+      <p:sp>
+        <p:nvSpPr>
+          <p:cNvPr id="54" name="TextBox 53"/>
           <p:cNvSpPr txBox="1"/>
           <p:nvPr/>
         </p:nvSpPr>
@@ -12824,14 +11522,14 @@
                 </a:solidFill>
                 <a:latin typeface="Calibri"/>
               </a:rPr>
-              <a:t>SBG Securities Downgrades Tencent Holdings to Hold From Buy; Price Target is HK$650</a:t>
-            </a:r>
-          </a:p>
-        </p:txBody>
-      </p:sp>
-      <p:sp>
-        <p:nvSpPr>
-          <p:cNvPr id="89" name="TextBox 88"/>
+              <a:t>Zephirin Adjusts Tencent Holdings' Price Target to HK$420 from HK$480, Keeps at Strong Sell</a:t>
+            </a:r>
+          </a:p>
+        </p:txBody>
+      </p:sp>
+      <p:sp>
+        <p:nvSpPr>
+          <p:cNvPr id="55" name="TextBox 54"/>
           <p:cNvSpPr txBox="1"/>
           <p:nvPr/>
         </p:nvSpPr>
@@ -12859,14 +11557,14 @@
                 </a:solidFill>
                 <a:latin typeface="Calibri"/>
               </a:rPr>
-              <a:t>Mar. 25</a:t>
-            </a:r>
-          </a:p>
-        </p:txBody>
-      </p:sp>
-      <p:sp>
-        <p:nvSpPr>
-          <p:cNvPr id="90" name="TextBox 89"/>
+              <a:t>02 Apr 2026</a:t>
+            </a:r>
+          </a:p>
+        </p:txBody>
+      </p:sp>
+      <p:sp>
+        <p:nvSpPr>
+          <p:cNvPr id="56" name="TextBox 55"/>
           <p:cNvSpPr txBox="1"/>
           <p:nvPr/>
         </p:nvSpPr>
@@ -12894,14 +11592,14 @@
                 </a:solidFill>
                 <a:latin typeface="Calibri"/>
               </a:rPr>
-              <a:t>Prosus Kept at Buy as BofA Notes Magnitude of Share Buyback; Forecasts Trimmed</a:t>
-            </a:r>
-          </a:p>
-        </p:txBody>
-      </p:sp>
-      <p:sp>
-        <p:nvSpPr>
-          <p:cNvPr id="91" name="Rectangle 90"/>
+              <a:t>SBG Securities Downgrades Tencent Holdings to Hold From Buy; Price Target is HK$650</a:t>
+            </a:r>
+          </a:p>
+        </p:txBody>
+      </p:sp>
+      <p:sp>
+        <p:nvSpPr>
+          <p:cNvPr id="57" name="Rectangle 56"/>
           <p:cNvSpPr/>
           <p:nvPr/>
         </p:nvSpPr>
@@ -12945,7 +11643,7 @@
       </p:sp>
       <p:sp>
         <p:nvSpPr>
-          <p:cNvPr id="92" name="TextBox 91"/>
+          <p:cNvPr id="58" name="TextBox 57"/>
           <p:cNvSpPr txBox="1"/>
           <p:nvPr/>
         </p:nvSpPr>
@@ -12973,14 +11671,14 @@
                 </a:solidFill>
                 <a:latin typeface="Calibri"/>
               </a:rPr>
-              <a:t>Source: investing, marketscreener, yahoo  |  Generated 14 May 2026  |  Analyst: Jabal Research</a:t>
-            </a:r>
-          </a:p>
-        </p:txBody>
-      </p:sp>
-      <p:sp>
-        <p:nvSpPr>
-          <p:cNvPr id="93" name="TextBox 92"/>
+              <a:t>Source: Investing.com, Yahoo Finance, MarketScreener, World Bank / IMF, iShares  |  Generated 17 May 2026  |  Analyst: Jabal Research</a:t>
+            </a:r>
+          </a:p>
+        </p:txBody>
+      </p:sp>
+      <p:sp>
+        <p:nvSpPr>
+          <p:cNvPr id="59" name="TextBox 58"/>
           <p:cNvSpPr txBox="1"/>
           <p:nvPr/>
         </p:nvSpPr>
@@ -13015,7 +11713,7 @@
       </p:sp>
       <p:sp>
         <p:nvSpPr>
-          <p:cNvPr id="94" name="TextBox 93"/>
+          <p:cNvPr id="60" name="TextBox 59"/>
           <p:cNvSpPr txBox="1"/>
           <p:nvPr/>
         </p:nvSpPr>
@@ -13050,7 +11748,7 @@
       </p:sp>
       <p:sp>
         <p:nvSpPr>
-          <p:cNvPr id="95" name="TextBox 94"/>
+          <p:cNvPr id="61" name="TextBox 60"/>
           <p:cNvSpPr txBox="1"/>
           <p:nvPr/>
         </p:nvSpPr>

</xml_diff>